<commit_message>
minor typos, font changes
</commit_message>
<xml_diff>
--- a/Slides/Module 04 Web Application Architecture.pptx
+++ b/Slides/Module 04 Web Application Architecture.pptx
@@ -5,7 +5,7 @@
     <p:sldMasterId id="2147483648" r:id="rId1"/>
   </p:sldMasterIdLst>
   <p:notesMasterIdLst>
-    <p:notesMasterId r:id="rId31"/>
+    <p:notesMasterId r:id="rId30"/>
   </p:notesMasterIdLst>
   <p:sldIdLst>
     <p:sldId id="485" r:id="rId2"/>
@@ -27,37 +27,36 @@
     <p:sldId id="757" r:id="rId18"/>
     <p:sldId id="728" r:id="rId19"/>
     <p:sldId id="798" r:id="rId20"/>
-    <p:sldId id="778" r:id="rId21"/>
-    <p:sldId id="758" r:id="rId22"/>
-    <p:sldId id="759" r:id="rId23"/>
-    <p:sldId id="779" r:id="rId24"/>
-    <p:sldId id="781" r:id="rId25"/>
-    <p:sldId id="783" r:id="rId26"/>
-    <p:sldId id="784" r:id="rId27"/>
-    <p:sldId id="785" r:id="rId28"/>
-    <p:sldId id="787" r:id="rId29"/>
-    <p:sldId id="735" r:id="rId30"/>
+    <p:sldId id="758" r:id="rId21"/>
+    <p:sldId id="759" r:id="rId22"/>
+    <p:sldId id="779" r:id="rId23"/>
+    <p:sldId id="781" r:id="rId24"/>
+    <p:sldId id="783" r:id="rId25"/>
+    <p:sldId id="784" r:id="rId26"/>
+    <p:sldId id="785" r:id="rId27"/>
+    <p:sldId id="787" r:id="rId28"/>
+    <p:sldId id="735" r:id="rId29"/>
   </p:sldIdLst>
   <p:sldSz cx="12192000" cy="6858000"/>
   <p:notesSz cx="6858000" cy="9144000"/>
   <p:embeddedFontLst>
     <p:embeddedFont>
       <p:font typeface="Andale Mono" panose="020B0604020202020204" charset="0"/>
-      <p:regular r:id="rId32"/>
+      <p:regular r:id="rId31"/>
     </p:embeddedFont>
     <p:embeddedFont>
       <p:font typeface="Consolas" panose="020B0609020204030204" pitchFamily="49" charset="0"/>
-      <p:regular r:id="rId33"/>
-      <p:bold r:id="rId34"/>
-      <p:italic r:id="rId35"/>
-      <p:boldItalic r:id="rId36"/>
+      <p:regular r:id="rId32"/>
+      <p:bold r:id="rId33"/>
+      <p:italic r:id="rId34"/>
+      <p:boldItalic r:id="rId35"/>
     </p:embeddedFont>
     <p:embeddedFont>
       <p:font typeface="Verdana" panose="020B0604030504040204" pitchFamily="34" charset="0"/>
-      <p:regular r:id="rId37"/>
-      <p:bold r:id="rId38"/>
-      <p:italic r:id="rId39"/>
-      <p:boldItalic r:id="rId40"/>
+      <p:regular r:id="rId36"/>
+      <p:bold r:id="rId37"/>
+      <p:italic r:id="rId38"/>
+      <p:boldItalic r:id="rId39"/>
     </p:embeddedFont>
   </p:embeddedFontLst>
   <p:defaultTextStyle>
@@ -179,7 +178,6 @@
             <p14:sldId id="757"/>
             <p14:sldId id="728"/>
             <p14:sldId id="798"/>
-            <p14:sldId id="778"/>
             <p14:sldId id="758"/>
             <p14:sldId id="759"/>
             <p14:sldId id="779"/>
@@ -190,12 +188,6 @@
             <p14:sldId id="787"/>
             <p14:sldId id="735"/>
           </p14:sldIdLst>
-        </p14:section>
-        <p14:section name="Scaling" id="{DEE2EA28-2A52-4F75-9468-580C4CD035B9}">
-          <p14:sldIdLst/>
-        </p14:section>
-        <p14:section name="Deleted Slides" id="{247BD5EC-53D9-4B3C-9075-96A89B075C87}">
-          <p14:sldIdLst/>
         </p14:section>
       </p14:sectionLst>
     </p:ext>
@@ -890,7 +882,7 @@
           <a:p>
             <a:fld id="{7C7E5181-6CF5-45F7-A87A-E0E0B1FD7549}" type="datetimeFigureOut">
               <a:rPr lang="en-US" smtClean="0"/>
-              <a:t>9/2/2026</a:t>
+              <a:t>9/7/2026</a:t>
             </a:fld>
             <a:endParaRPr lang="en-US"/>
           </a:p>
@@ -1940,7 +1932,7 @@
           <a:p>
             <a:fld id="{3927C2FE-14BE-B74D-96F0-2A5DC4BF0069}" type="slidenum">
               <a:rPr lang="en-US" smtClean="0"/>
-              <a:t>21</a:t>
+              <a:t>20</a:t>
             </a:fld>
             <a:endParaRPr lang="en-US"/>
           </a:p>
@@ -2095,7 +2087,7 @@
                 <a:tabLst/>
                 <a:defRPr/>
               </a:pPr>
-              <a:t>22</a:t>
+              <a:t>21</a:t>
             </a:fld>
             <a:endParaRPr kumimoji="0" lang="en-US" sz="1200" b="0" i="0" u="none" strike="noStrike" kern="1200" cap="none" spc="0" normalizeH="0" baseline="0" noProof="0">
               <a:ln>
@@ -2223,7 +2215,7 @@
           <a:p>
             <a:fld id="{07937F07-1250-4CCE-B198-1B2887014F41}" type="slidenum">
               <a:rPr lang="en-US" smtClean="0"/>
-              <a:t>23</a:t>
+              <a:t>22</a:t>
             </a:fld>
             <a:endParaRPr lang="en-US"/>
           </a:p>
@@ -2314,7 +2306,7 @@
           <a:p>
             <a:fld id="{07937F07-1250-4CCE-B198-1B2887014F41}" type="slidenum">
               <a:rPr lang="en-US" smtClean="0"/>
-              <a:t>25</a:t>
+              <a:t>24</a:t>
             </a:fld>
             <a:endParaRPr lang="en-US"/>
           </a:p>
@@ -2422,7 +2414,7 @@
           <a:p>
             <a:fld id="{07937F07-1250-4CCE-B198-1B2887014F41}" type="slidenum">
               <a:rPr lang="en-US" smtClean="0"/>
-              <a:t>26</a:t>
+              <a:t>25</a:t>
             </a:fld>
             <a:endParaRPr lang="en-US"/>
           </a:p>
@@ -2506,7 +2498,7 @@
           <a:p>
             <a:fld id="{07937F07-1250-4CCE-B198-1B2887014F41}" type="slidenum">
               <a:rPr lang="en-US" smtClean="0"/>
-              <a:t>29</a:t>
+              <a:t>28</a:t>
             </a:fld>
             <a:endParaRPr lang="en-US"/>
           </a:p>
@@ -4084,7 +4076,7 @@
           <a:p>
             <a:fld id="{5D2A64DE-480B-420F-9649-4F8E696E08E0}" type="datetime1">
               <a:rPr lang="en-US" smtClean="0"/>
-              <a:t>9/2/2026</a:t>
+              <a:t>9/7/2026</a:t>
             </a:fld>
             <a:endParaRPr lang="en-US"/>
           </a:p>
@@ -4408,7 +4400,7 @@
           <a:p>
             <a:fld id="{EA476A42-A091-4468-A075-64A31BE59948}" type="datetime1">
               <a:rPr lang="en-US" smtClean="0"/>
-              <a:t>9/2/2026</a:t>
+              <a:t>9/7/2026</a:t>
             </a:fld>
             <a:endParaRPr lang="en-US"/>
           </a:p>
@@ -4606,7 +4598,7 @@
           <a:p>
             <a:fld id="{0D3616D0-8311-4107-9726-6B805E7D05BA}" type="datetime1">
               <a:rPr lang="en-US" smtClean="0"/>
-              <a:t>9/2/2026</a:t>
+              <a:t>9/7/2026</a:t>
             </a:fld>
             <a:endParaRPr lang="en-US"/>
           </a:p>
@@ -4814,7 +4806,7 @@
           <a:p>
             <a:fld id="{3BC2557A-5C88-417A-A763-5AC779462A5F}" type="datetime1">
               <a:rPr lang="en-US" smtClean="0"/>
-              <a:t>9/2/2026</a:t>
+              <a:t>9/7/2026</a:t>
             </a:fld>
             <a:endParaRPr lang="en-US"/>
           </a:p>
@@ -5236,7 +5228,7 @@
           <a:p>
             <a:fld id="{07C7BFD4-467E-4EDE-93EA-052F5B39A4E5}" type="datetime1">
               <a:rPr lang="en-US" smtClean="0"/>
-              <a:t>9/2/2026</a:t>
+              <a:t>9/7/2026</a:t>
             </a:fld>
             <a:endParaRPr lang="en-US"/>
           </a:p>
@@ -5486,7 +5478,7 @@
           <a:p>
             <a:fld id="{07C7BFD4-467E-4EDE-93EA-052F5B39A4E5}" type="datetime1">
               <a:rPr lang="en-US" smtClean="0"/>
-              <a:t>9/2/2026</a:t>
+              <a:t>9/7/2026</a:t>
             </a:fld>
             <a:endParaRPr lang="en-US"/>
           </a:p>
@@ -5668,7 +5660,7 @@
           <a:p>
             <a:fld id="{109E55A0-C911-4F03-82FC-7E5926047D46}" type="datetime1">
               <a:rPr lang="en-US" smtClean="0"/>
-              <a:t>9/2/2026</a:t>
+              <a:t>9/7/2026</a:t>
             </a:fld>
             <a:endParaRPr lang="en-US"/>
           </a:p>
@@ -5981,7 +5973,7 @@
           <a:p>
             <a:fld id="{A533CBE2-D5BE-47AC-ADC2-9CDFC1D0CF90}" type="datetime1">
               <a:rPr lang="en-US" smtClean="0"/>
-              <a:t>9/2/2026</a:t>
+              <a:t>9/7/2026</a:t>
             </a:fld>
             <a:endParaRPr lang="en-US"/>
           </a:p>
@@ -6282,7 +6274,7 @@
           <a:p>
             <a:fld id="{39B7EDB1-CE74-4951-85A2-0B01C2128E28}" type="datetime1">
               <a:rPr lang="en-US" smtClean="0"/>
-              <a:t>9/2/2026</a:t>
+              <a:t>9/7/2026</a:t>
             </a:fld>
             <a:endParaRPr lang="en-US"/>
           </a:p>
@@ -6730,7 +6722,7 @@
           <a:p>
             <a:fld id="{2BC7EB92-A5C2-4807-A9DC-9EDE6CBFB241}" type="datetime1">
               <a:rPr lang="en-US" smtClean="0"/>
-              <a:t>9/2/2026</a:t>
+              <a:t>9/7/2026</a:t>
             </a:fld>
             <a:endParaRPr lang="en-US"/>
           </a:p>
@@ -6843,7 +6835,7 @@
           <a:p>
             <a:fld id="{2B7B7EE0-7771-4CD5-9B2B-3550753A54A1}" type="datetime1">
               <a:rPr lang="en-US" smtClean="0"/>
-              <a:t>9/2/2026</a:t>
+              <a:t>9/7/2026</a:t>
             </a:fld>
             <a:endParaRPr lang="en-US"/>
           </a:p>
@@ -7154,7 +7146,7 @@
           <a:p>
             <a:fld id="{F8B318B3-0E87-4416-A9B8-D891968C2727}" type="datetime1">
               <a:rPr lang="en-US" smtClean="0"/>
-              <a:t>9/2/2026</a:t>
+              <a:t>9/7/2026</a:t>
             </a:fld>
             <a:endParaRPr lang="en-US"/>
           </a:p>
@@ -7395,7 +7387,7 @@
           <a:p>
             <a:fld id="{54D997E8-DDEE-43F1-8D9B-F8A1E11DE488}" type="datetime1">
               <a:rPr lang="en-US" smtClean="0"/>
-              <a:t>9/2/2026</a:t>
+              <a:t>9/7/2026</a:t>
             </a:fld>
             <a:endParaRPr lang="en-US"/>
           </a:p>
@@ -7849,6 +7841,11 @@
                 <a:sym typeface="Helvetica Neue" charset="0"/>
               </a:rPr>
             </a:br>
+            <a:br>
+              <a:rPr lang="en-US" altLang="en-US" dirty="0">
+                <a:sym typeface="Helvetica Neue" charset="0"/>
+              </a:rPr>
+            </a:br>
             <a:r>
               <a:rPr lang="en-US" altLang="en-US" dirty="0">
                 <a:sym typeface="Helvetica Neue" charset="0"/>
@@ -13306,11 +13303,13 @@
         </p:nvSpPr>
         <p:spPr/>
         <p:txBody>
-          <a:bodyPr/>
+          <a:bodyPr>
+            <a:normAutofit/>
+          </a:bodyPr>
           <a:lstStyle/>
           <a:p>
             <a:r>
-              <a:rPr lang="en-US" dirty="0"/>
+              <a:rPr lang="en-US" sz="3600" dirty="0"/>
               <a:t>First, we add validation to the controller (here using Zod)</a:t>
             </a:r>
           </a:p>
@@ -15187,12 +15186,12 @@
         <p:spPr/>
         <p:txBody>
           <a:bodyPr>
-            <a:normAutofit fontScale="90000"/>
+            <a:normAutofit/>
           </a:bodyPr>
           <a:lstStyle/>
           <a:p>
             <a:r>
-              <a:rPr lang="en-US" dirty="0"/>
+              <a:rPr lang="en-US" sz="3600" dirty="0"/>
               <a:t>The controller relies on the service layer to perform the appropriate actions</a:t>
             </a:r>
           </a:p>
@@ -20493,118 +20492,6 @@
   <p:cSld>
     <p:spTree>
       <p:nvGrpSpPr>
-        <p:cNvPr id="1" name=""/>
-        <p:cNvGrpSpPr/>
-        <p:nvPr/>
-      </p:nvGrpSpPr>
-      <p:grpSpPr>
-        <a:xfrm>
-          <a:off x="0" y="0"/>
-          <a:ext cx="0" cy="0"/>
-          <a:chOff x="0" y="0"/>
-          <a:chExt cx="0" cy="0"/>
-        </a:xfrm>
-      </p:grpSpPr>
-      <p:sp>
-        <p:nvSpPr>
-          <p:cNvPr id="2" name="Title 1">
-            <a:extLst>
-              <a:ext uri="{FF2B5EF4-FFF2-40B4-BE49-F238E27FC236}">
-                <a16:creationId xmlns:a16="http://schemas.microsoft.com/office/drawing/2014/main" id="{D71480DC-79A9-A0E5-AF4B-F0D07BBBC51A}"/>
-              </a:ext>
-            </a:extLst>
-          </p:cNvPr>
-          <p:cNvSpPr>
-            <a:spLocks noGrp="1"/>
-          </p:cNvSpPr>
-          <p:nvPr>
-            <p:ph type="title"/>
-          </p:nvPr>
-        </p:nvSpPr>
-        <p:spPr/>
-        <p:txBody>
-          <a:bodyPr/>
-          <a:lstStyle/>
-          <a:p>
-            <a:r>
-              <a:rPr lang="en-US" dirty="0"/>
-              <a:t>4.3 The Repository Layer</a:t>
-            </a:r>
-          </a:p>
-        </p:txBody>
-      </p:sp>
-      <p:sp>
-        <p:nvSpPr>
-          <p:cNvPr id="3" name="Content Placeholder 2">
-            <a:extLst>
-              <a:ext uri="{FF2B5EF4-FFF2-40B4-BE49-F238E27FC236}">
-                <a16:creationId xmlns:a16="http://schemas.microsoft.com/office/drawing/2014/main" id="{E666A41D-A78F-55BB-93F3-43479609AF2C}"/>
-              </a:ext>
-            </a:extLst>
-          </p:cNvPr>
-          <p:cNvSpPr>
-            <a:spLocks noGrp="1"/>
-          </p:cNvSpPr>
-          <p:nvPr>
-            <p:ph idx="1"/>
-          </p:nvPr>
-        </p:nvSpPr>
-        <p:spPr/>
-        <p:txBody>
-          <a:bodyPr/>
-          <a:lstStyle/>
-          <a:p>
-            <a:endParaRPr lang="en-US" dirty="0"/>
-          </a:p>
-        </p:txBody>
-      </p:sp>
-      <p:sp>
-        <p:nvSpPr>
-          <p:cNvPr id="4" name="Slide Number Placeholder 3">
-            <a:extLst>
-              <a:ext uri="{FF2B5EF4-FFF2-40B4-BE49-F238E27FC236}">
-                <a16:creationId xmlns:a16="http://schemas.microsoft.com/office/drawing/2014/main" id="{97DF7597-A398-D003-ACA8-121E09B8D202}"/>
-              </a:ext>
-            </a:extLst>
-          </p:cNvPr>
-          <p:cNvSpPr>
-            <a:spLocks noGrp="1"/>
-          </p:cNvSpPr>
-          <p:nvPr>
-            <p:ph type="sldNum" sz="quarter" idx="12"/>
-          </p:nvPr>
-        </p:nvSpPr>
-        <p:spPr/>
-        <p:txBody>
-          <a:bodyPr/>
-          <a:lstStyle/>
-          <a:p>
-            <a:fld id="{20F37917-FD3A-4669-9018-DA04BCDD3D75}" type="slidenum">
-              <a:rPr lang="en-US" smtClean="0"/>
-              <a:t>20</a:t>
-            </a:fld>
-            <a:endParaRPr lang="en-US"/>
-          </a:p>
-        </p:txBody>
-      </p:sp>
-    </p:spTree>
-    <p:extLst>
-      <p:ext uri="{BB962C8B-B14F-4D97-AF65-F5344CB8AC3E}">
-        <p14:creationId xmlns:p14="http://schemas.microsoft.com/office/powerpoint/2010/main" val="3075355761"/>
-      </p:ext>
-    </p:extLst>
-  </p:cSld>
-  <p:clrMapOvr>
-    <a:masterClrMapping/>
-  </p:clrMapOvr>
-</p:sld>
-</file>
-
-<file path=ppt/slides/slide21.xml><?xml version="1.0" encoding="utf-8"?>
-<p:sld xmlns:a="http://schemas.openxmlformats.org/drawingml/2006/main" xmlns:r="http://schemas.openxmlformats.org/officeDocument/2006/relationships" xmlns:p="http://schemas.openxmlformats.org/presentationml/2006/main">
-  <p:cSld>
-    <p:spTree>
-      <p:nvGrpSpPr>
         <p:cNvPr id="1" name="">
           <a:extLst>
             <a:ext uri="{FF2B5EF4-FFF2-40B4-BE49-F238E27FC236}">
@@ -20646,7 +20533,7 @@
           <a:p>
             <a:r>
               <a:rPr lang="en-US" dirty="0"/>
-              <a:t>A Repository Layer should provide persistence</a:t>
+              <a:t>4.3 A Repository Layer should provide persistence</a:t>
             </a:r>
           </a:p>
         </p:txBody>
@@ -20749,7 +20636,7 @@
           <a:p>
             <a:fld id="{20F37917-FD3A-4669-9018-DA04BCDD3D75}" type="slidenum">
               <a:rPr lang="en-US" smtClean="0"/>
-              <a:t>21</a:t>
+              <a:t>20</a:t>
             </a:fld>
             <a:endParaRPr lang="en-US" dirty="0"/>
           </a:p>
@@ -20827,7 +20714,7 @@
 </p:sld>
 </file>
 
-<file path=ppt/slides/slide22.xml><?xml version="1.0" encoding="utf-8"?>
+<file path=ppt/slides/slide21.xml><?xml version="1.0" encoding="utf-8"?>
 <p:sld xmlns:a="http://schemas.openxmlformats.org/drawingml/2006/main" xmlns:r="http://schemas.openxmlformats.org/officeDocument/2006/relationships" xmlns:p="http://schemas.openxmlformats.org/presentationml/2006/main">
   <p:cSld>
     <p:spTree>
@@ -21054,7 +20941,7 @@
 </p:sld>
 </file>
 
-<file path=ppt/slides/slide23.xml><?xml version="1.0" encoding="utf-8"?>
+<file path=ppt/slides/slide22.xml><?xml version="1.0" encoding="utf-8"?>
 <p:sld xmlns:a="http://schemas.openxmlformats.org/drawingml/2006/main" xmlns:r="http://schemas.openxmlformats.org/officeDocument/2006/relationships" xmlns:p="http://schemas.openxmlformats.org/presentationml/2006/main">
   <p:cSld>
     <p:spTree>
@@ -21183,7 +21070,7 @@
           <a:p>
             <a:fld id="{20F37917-FD3A-4669-9018-DA04BCDD3D75}" type="slidenum">
               <a:rPr lang="en-US" smtClean="0"/>
-              <a:t>23</a:t>
+              <a:t>22</a:t>
             </a:fld>
             <a:endParaRPr lang="en-US"/>
           </a:p>
@@ -21202,7 +21089,7 @@
 </p:sld>
 </file>
 
-<file path=ppt/slides/slide24.xml><?xml version="1.0" encoding="utf-8"?>
+<file path=ppt/slides/slide23.xml><?xml version="1.0" encoding="utf-8"?>
 <p:sld xmlns:a="http://schemas.openxmlformats.org/drawingml/2006/main" xmlns:r="http://schemas.openxmlformats.org/officeDocument/2006/relationships" xmlns:p="http://schemas.openxmlformats.org/presentationml/2006/main">
   <p:cSld>
     <p:spTree>
@@ -21270,7 +21157,7 @@
           <a:p>
             <a:fld id="{20F37917-FD3A-4669-9018-DA04BCDD3D75}" type="slidenum">
               <a:rPr lang="en-US" smtClean="0"/>
-              <a:t>24</a:t>
+              <a:t>23</a:t>
             </a:fld>
             <a:endParaRPr lang="en-US"/>
           </a:p>
@@ -21290,8 +21177,8 @@
         </p:nvSpPr>
         <p:spPr>
           <a:xfrm>
-            <a:off x="252662" y="1629555"/>
-            <a:ext cx="11730791" cy="4154984"/>
+            <a:off x="838200" y="1629555"/>
+            <a:ext cx="11145253" cy="3477875"/>
           </a:xfrm>
           <a:prstGeom prst="rect">
             <a:avLst/>
@@ -21330,7 +21217,7 @@
               <a:buNone/>
             </a:pPr>
             <a:r>
-              <a:rPr lang="en-US" sz="2400" b="0" dirty="0">
+              <a:rPr lang="en-US" sz="2000" b="0" dirty="0">
                 <a:solidFill>
                   <a:srgbClr val="AF00DB"/>
                 </a:solidFill>
@@ -21340,7 +21227,7 @@
               <a:t>export</a:t>
             </a:r>
             <a:r>
-              <a:rPr lang="en-US" sz="2400" b="0" dirty="0">
+              <a:rPr lang="en-US" sz="2000" b="0" dirty="0">
                 <a:solidFill>
                   <a:srgbClr val="3B3B3B"/>
                 </a:solidFill>
@@ -21350,7 +21237,7 @@
               <a:t> </a:t>
             </a:r>
             <a:r>
-              <a:rPr lang="en-US" sz="2400" b="0" dirty="0">
+              <a:rPr lang="en-US" sz="2000" b="0" dirty="0">
                 <a:solidFill>
                   <a:srgbClr val="0000FF"/>
                 </a:solidFill>
@@ -21360,7 +21247,7 @@
               <a:t>interface</a:t>
             </a:r>
             <a:r>
-              <a:rPr lang="en-US" sz="2400" b="0" dirty="0">
+              <a:rPr lang="en-US" sz="2000" b="0" dirty="0">
                 <a:solidFill>
                   <a:srgbClr val="3B3B3B"/>
                 </a:solidFill>
@@ -21370,7 +21257,7 @@
               <a:t> </a:t>
             </a:r>
             <a:r>
-              <a:rPr lang="en-US" sz="2400" b="0" dirty="0" err="1">
+              <a:rPr lang="en-US" sz="2000" b="0" dirty="0" err="1">
                 <a:solidFill>
                   <a:srgbClr val="267F99"/>
                 </a:solidFill>
@@ -21380,7 +21267,7 @@
               <a:t>ITranscriptRepo</a:t>
             </a:r>
             <a:r>
-              <a:rPr lang="en-US" sz="2400" b="0" dirty="0">
+              <a:rPr lang="en-US" sz="2000" b="0" dirty="0">
                 <a:solidFill>
                   <a:srgbClr val="3B3B3B"/>
                 </a:solidFill>
@@ -21395,7 +21282,7 @@
               <a:buNone/>
             </a:pPr>
             <a:r>
-              <a:rPr lang="en-US" sz="2400" b="0" dirty="0">
+              <a:rPr lang="en-US" sz="2000" b="0" dirty="0">
                 <a:solidFill>
                   <a:srgbClr val="3B3B3B"/>
                 </a:solidFill>
@@ -21405,7 +21292,7 @@
               <a:t>  </a:t>
             </a:r>
             <a:r>
-              <a:rPr lang="en-US" sz="2400" b="0" dirty="0" err="1">
+              <a:rPr lang="en-US" sz="2000" b="0" dirty="0" err="1">
                 <a:solidFill>
                   <a:srgbClr val="795E26"/>
                 </a:solidFill>
@@ -21415,7 +21302,7 @@
               <a:t>addStudent</a:t>
             </a:r>
             <a:r>
-              <a:rPr lang="en-US" sz="2400" b="0" dirty="0">
+              <a:rPr lang="en-US" sz="2000" b="0" dirty="0">
                 <a:solidFill>
                   <a:srgbClr val="3B3B3B"/>
                 </a:solidFill>
@@ -21425,7 +21312,7 @@
               <a:t>(</a:t>
             </a:r>
             <a:r>
-              <a:rPr lang="en-US" sz="2400" b="0" dirty="0" err="1">
+              <a:rPr lang="en-US" sz="2000" b="0" dirty="0" err="1">
                 <a:solidFill>
                   <a:srgbClr val="001080"/>
                 </a:solidFill>
@@ -21435,7 +21322,7 @@
               <a:t>studentName</a:t>
             </a:r>
             <a:r>
-              <a:rPr lang="en-US" sz="2400" b="0" dirty="0">
+              <a:rPr lang="en-US" sz="2000" b="0" dirty="0">
                 <a:solidFill>
                   <a:srgbClr val="000000"/>
                 </a:solidFill>
@@ -21445,7 +21332,7 @@
               <a:t>:</a:t>
             </a:r>
             <a:r>
-              <a:rPr lang="en-US" sz="2400" b="0" dirty="0">
+              <a:rPr lang="en-US" sz="2000" b="0" dirty="0">
                 <a:solidFill>
                   <a:srgbClr val="3B3B3B"/>
                 </a:solidFill>
@@ -21455,7 +21342,7 @@
               <a:t> </a:t>
             </a:r>
             <a:r>
-              <a:rPr lang="en-US" sz="2400" b="0" dirty="0">
+              <a:rPr lang="en-US" sz="2000" b="0" dirty="0">
                 <a:solidFill>
                   <a:srgbClr val="267F99"/>
                 </a:solidFill>
@@ -21465,7 +21352,7 @@
               <a:t>string</a:t>
             </a:r>
             <a:r>
-              <a:rPr lang="en-US" sz="2400" b="0" dirty="0">
+              <a:rPr lang="en-US" sz="2000" b="0" dirty="0">
                 <a:solidFill>
                   <a:srgbClr val="3B3B3B"/>
                 </a:solidFill>
@@ -21475,7 +21362,7 @@
               <a:t>)</a:t>
             </a:r>
             <a:r>
-              <a:rPr lang="en-US" sz="2400" b="0" dirty="0">
+              <a:rPr lang="en-US" sz="2000" b="0" dirty="0">
                 <a:solidFill>
                   <a:srgbClr val="000000"/>
                 </a:solidFill>
@@ -21485,7 +21372,7 @@
               <a:t>:</a:t>
             </a:r>
             <a:r>
-              <a:rPr lang="en-US" sz="2400" b="0" dirty="0">
+              <a:rPr lang="en-US" sz="2000" b="0" dirty="0">
                 <a:solidFill>
                   <a:srgbClr val="3B3B3B"/>
                 </a:solidFill>
@@ -21495,7 +21382,7 @@
               <a:t> </a:t>
             </a:r>
             <a:r>
-              <a:rPr lang="en-US" sz="2400" b="0" dirty="0">
+              <a:rPr lang="en-US" sz="2000" b="0" dirty="0">
                 <a:solidFill>
                   <a:srgbClr val="267F99"/>
                 </a:solidFill>
@@ -21508,7 +21395,7 @@
               <a:t>Promise</a:t>
             </a:r>
             <a:r>
-              <a:rPr lang="en-US" sz="2400" b="0" dirty="0">
+              <a:rPr lang="en-US" sz="2000" b="0" dirty="0">
                 <a:solidFill>
                   <a:srgbClr val="3B3B3B"/>
                 </a:solidFill>
@@ -21518,7 +21405,7 @@
               <a:t>&lt;</a:t>
             </a:r>
             <a:r>
-              <a:rPr lang="en-US" sz="2400" b="0" dirty="0" err="1">
+              <a:rPr lang="en-US" sz="2000" b="0" dirty="0" err="1">
                 <a:solidFill>
                   <a:srgbClr val="267F99"/>
                 </a:solidFill>
@@ -21528,7 +21415,7 @@
               <a:t>StudentID</a:t>
             </a:r>
             <a:r>
-              <a:rPr lang="en-US" sz="2400" b="0" dirty="0">
+              <a:rPr lang="en-US" sz="2000" b="0" dirty="0">
                 <a:solidFill>
                   <a:srgbClr val="3B3B3B"/>
                 </a:solidFill>
@@ -21543,7 +21430,7 @@
               <a:buNone/>
             </a:pPr>
             <a:r>
-              <a:rPr lang="en-US" sz="2400" b="0" dirty="0">
+              <a:rPr lang="en-US" sz="2000" b="0" dirty="0">
                 <a:solidFill>
                   <a:srgbClr val="3B3B3B"/>
                 </a:solidFill>
@@ -21553,7 +21440,7 @@
               <a:t>  </a:t>
             </a:r>
             <a:r>
-              <a:rPr lang="en-US" sz="2400" b="0" dirty="0" err="1">
+              <a:rPr lang="en-US" sz="2000" b="0" dirty="0" err="1">
                 <a:solidFill>
                   <a:srgbClr val="795E26"/>
                 </a:solidFill>
@@ -21563,7 +21450,7 @@
               <a:t>getTranscript</a:t>
             </a:r>
             <a:r>
-              <a:rPr lang="en-US" sz="2400" b="0" dirty="0">
+              <a:rPr lang="en-US" sz="2000" b="0" dirty="0">
                 <a:solidFill>
                   <a:srgbClr val="3B3B3B"/>
                 </a:solidFill>
@@ -21573,7 +21460,7 @@
               <a:t>(</a:t>
             </a:r>
             <a:r>
-              <a:rPr lang="en-US" sz="2400" b="0" dirty="0">
+              <a:rPr lang="en-US" sz="2000" b="0" dirty="0">
                 <a:solidFill>
                   <a:srgbClr val="001080"/>
                 </a:solidFill>
@@ -21583,7 +21470,7 @@
               <a:t>id</a:t>
             </a:r>
             <a:r>
-              <a:rPr lang="en-US" sz="2400" b="0" dirty="0">
+              <a:rPr lang="en-US" sz="2000" b="0" dirty="0">
                 <a:solidFill>
                   <a:srgbClr val="000000"/>
                 </a:solidFill>
@@ -21593,7 +21480,7 @@
               <a:t>:</a:t>
             </a:r>
             <a:r>
-              <a:rPr lang="en-US" sz="2400" b="0" dirty="0">
+              <a:rPr lang="en-US" sz="2000" b="0" dirty="0">
                 <a:solidFill>
                   <a:srgbClr val="3B3B3B"/>
                 </a:solidFill>
@@ -21603,7 +21490,7 @@
               <a:t> </a:t>
             </a:r>
             <a:r>
-              <a:rPr lang="en-US" sz="2400" b="0" dirty="0" err="1">
+              <a:rPr lang="en-US" sz="2000" b="0" dirty="0" err="1">
                 <a:solidFill>
                   <a:srgbClr val="267F99"/>
                 </a:solidFill>
@@ -21613,7 +21500,7 @@
               <a:t>StudentID</a:t>
             </a:r>
             <a:r>
-              <a:rPr lang="en-US" sz="2400" b="0" dirty="0">
+              <a:rPr lang="en-US" sz="2000" b="0" dirty="0">
                 <a:solidFill>
                   <a:srgbClr val="3B3B3B"/>
                 </a:solidFill>
@@ -21623,7 +21510,7 @@
               <a:t>)</a:t>
             </a:r>
             <a:r>
-              <a:rPr lang="en-US" sz="2400" b="0" dirty="0">
+              <a:rPr lang="en-US" sz="2000" b="0" dirty="0">
                 <a:solidFill>
                   <a:srgbClr val="000000"/>
                 </a:solidFill>
@@ -21633,7 +21520,7 @@
               <a:t>:</a:t>
             </a:r>
             <a:r>
-              <a:rPr lang="en-US" sz="2400" b="0" dirty="0">
+              <a:rPr lang="en-US" sz="2000" b="0" dirty="0">
                 <a:solidFill>
                   <a:srgbClr val="3B3B3B"/>
                 </a:solidFill>
@@ -21643,7 +21530,7 @@
               <a:t> </a:t>
             </a:r>
             <a:r>
-              <a:rPr lang="en-US" sz="2400" b="0" dirty="0">
+              <a:rPr lang="en-US" sz="2000" b="0" dirty="0">
                 <a:solidFill>
                   <a:srgbClr val="267F99"/>
                 </a:solidFill>
@@ -21656,7 +21543,7 @@
               <a:t>Promise</a:t>
             </a:r>
             <a:r>
-              <a:rPr lang="en-US" sz="2400" b="0" dirty="0">
+              <a:rPr lang="en-US" sz="2000" b="0" dirty="0">
                 <a:solidFill>
                   <a:srgbClr val="3B3B3B"/>
                 </a:solidFill>
@@ -21666,7 +21553,7 @@
               <a:t>&lt;</a:t>
             </a:r>
             <a:r>
-              <a:rPr lang="en-US" sz="2400" b="0" dirty="0">
+              <a:rPr lang="en-US" sz="2000" b="0" dirty="0">
                 <a:solidFill>
                   <a:srgbClr val="267F99"/>
                 </a:solidFill>
@@ -21676,7 +21563,7 @@
               <a:t>Transcript</a:t>
             </a:r>
             <a:r>
-              <a:rPr lang="en-US" sz="2400" b="0" dirty="0">
+              <a:rPr lang="en-US" sz="2000" b="0" dirty="0">
                 <a:solidFill>
                   <a:srgbClr val="3B3B3B"/>
                 </a:solidFill>
@@ -21691,7 +21578,7 @@
               <a:buNone/>
             </a:pPr>
             <a:r>
-              <a:rPr lang="en-US" sz="2400" dirty="0">
+              <a:rPr lang="en-US" sz="2000" dirty="0">
                 <a:solidFill>
                   <a:srgbClr val="3B3B3B"/>
                 </a:solidFill>
@@ -21700,7 +21587,7 @@
               <a:t>        </a:t>
             </a:r>
             <a:r>
-              <a:rPr lang="en-US" sz="2400" b="0" dirty="0">
+              <a:rPr lang="en-US" sz="2000" b="0" dirty="0">
                 <a:solidFill>
                   <a:srgbClr val="008000"/>
                 </a:solidFill>
@@ -21709,7 +21596,7 @@
               </a:rPr>
               <a:t>// promise is if id invalid</a:t>
             </a:r>
-            <a:endParaRPr lang="en-US" sz="2400" b="0" dirty="0">
+            <a:endParaRPr lang="en-US" sz="2000" b="0" dirty="0">
               <a:solidFill>
                 <a:srgbClr val="3B3B3B"/>
               </a:solidFill>
@@ -21722,7 +21609,7 @@
               <a:buNone/>
             </a:pPr>
             <a:r>
-              <a:rPr lang="en-US" sz="2400" b="0" dirty="0">
+              <a:rPr lang="en-US" sz="2000" b="0" dirty="0">
                 <a:solidFill>
                   <a:srgbClr val="3B3B3B"/>
                 </a:solidFill>
@@ -21732,7 +21619,7 @@
               <a:t>  </a:t>
             </a:r>
             <a:r>
-              <a:rPr lang="en-US" sz="2400" b="0" dirty="0" err="1">
+              <a:rPr lang="en-US" sz="2000" b="0" dirty="0" err="1">
                 <a:solidFill>
                   <a:srgbClr val="795E26"/>
                 </a:solidFill>
@@ -21742,7 +21629,7 @@
               <a:t>deleteStudent</a:t>
             </a:r>
             <a:r>
-              <a:rPr lang="en-US" sz="2400" b="0" dirty="0">
+              <a:rPr lang="en-US" sz="2000" b="0" dirty="0">
                 <a:solidFill>
                   <a:srgbClr val="3B3B3B"/>
                 </a:solidFill>
@@ -21752,7 +21639,7 @@
               <a:t>(</a:t>
             </a:r>
             <a:r>
-              <a:rPr lang="en-US" sz="2400" b="0" dirty="0">
+              <a:rPr lang="en-US" sz="2000" b="0" dirty="0">
                 <a:solidFill>
                   <a:srgbClr val="001080"/>
                 </a:solidFill>
@@ -21762,7 +21649,7 @@
               <a:t>id</a:t>
             </a:r>
             <a:r>
-              <a:rPr lang="en-US" sz="2400" b="0" dirty="0">
+              <a:rPr lang="en-US" sz="2000" b="0" dirty="0">
                 <a:solidFill>
                   <a:srgbClr val="000000"/>
                 </a:solidFill>
@@ -21772,7 +21659,7 @@
               <a:t>:</a:t>
             </a:r>
             <a:r>
-              <a:rPr lang="en-US" sz="2400" b="0" dirty="0">
+              <a:rPr lang="en-US" sz="2000" b="0" dirty="0">
                 <a:solidFill>
                   <a:srgbClr val="3B3B3B"/>
                 </a:solidFill>
@@ -21782,7 +21669,7 @@
               <a:t> </a:t>
             </a:r>
             <a:r>
-              <a:rPr lang="en-US" sz="2400" b="0" dirty="0" err="1">
+              <a:rPr lang="en-US" sz="2000" b="0" dirty="0" err="1">
                 <a:solidFill>
                   <a:srgbClr val="267F99"/>
                 </a:solidFill>
@@ -21792,7 +21679,7 @@
               <a:t>StudentID</a:t>
             </a:r>
             <a:r>
-              <a:rPr lang="en-US" sz="2400" b="0" dirty="0">
+              <a:rPr lang="en-US" sz="2000" b="0" dirty="0">
                 <a:solidFill>
                   <a:srgbClr val="3B3B3B"/>
                 </a:solidFill>
@@ -21802,7 +21689,7 @@
               <a:t>)</a:t>
             </a:r>
             <a:r>
-              <a:rPr lang="en-US" sz="2400" b="0" dirty="0">
+              <a:rPr lang="en-US" sz="2000" b="0" dirty="0">
                 <a:solidFill>
                   <a:srgbClr val="000000"/>
                 </a:solidFill>
@@ -21812,7 +21699,7 @@
               <a:t>:</a:t>
             </a:r>
             <a:r>
-              <a:rPr lang="en-US" sz="2400" b="0" dirty="0">
+              <a:rPr lang="en-US" sz="2000" b="0" dirty="0">
                 <a:solidFill>
                   <a:srgbClr val="3B3B3B"/>
                 </a:solidFill>
@@ -21822,7 +21709,7 @@
               <a:t> </a:t>
             </a:r>
             <a:r>
-              <a:rPr lang="en-US" sz="2400" b="0" dirty="0">
+              <a:rPr lang="en-US" sz="2000" b="0" dirty="0">
                 <a:solidFill>
                   <a:srgbClr val="267F99"/>
                 </a:solidFill>
@@ -21835,7 +21722,7 @@
               <a:t>Promise</a:t>
             </a:r>
             <a:r>
-              <a:rPr lang="en-US" sz="2400" b="0" dirty="0">
+              <a:rPr lang="en-US" sz="2000" b="0" dirty="0">
                 <a:solidFill>
                   <a:srgbClr val="3B3B3B"/>
                 </a:solidFill>
@@ -21845,7 +21732,7 @@
               <a:t>&lt;</a:t>
             </a:r>
             <a:r>
-              <a:rPr lang="en-US" sz="2400" b="0" dirty="0">
+              <a:rPr lang="en-US" sz="2000" b="0" dirty="0">
                 <a:solidFill>
                   <a:srgbClr val="267F99"/>
                 </a:solidFill>
@@ -21855,7 +21742,7 @@
               <a:t>void</a:t>
             </a:r>
             <a:r>
-              <a:rPr lang="en-US" sz="2400" b="0" dirty="0">
+              <a:rPr lang="en-US" sz="2000" b="0" dirty="0">
                 <a:solidFill>
                   <a:srgbClr val="3B3B3B"/>
                 </a:solidFill>
@@ -21870,7 +21757,7 @@
               <a:buNone/>
             </a:pPr>
             <a:r>
-              <a:rPr lang="en-US" sz="2400" dirty="0">
+              <a:rPr lang="en-US" sz="2000" dirty="0">
                 <a:solidFill>
                   <a:srgbClr val="3B3B3B"/>
                 </a:solidFill>
@@ -21879,7 +21766,7 @@
               <a:t>        </a:t>
             </a:r>
             <a:r>
-              <a:rPr lang="en-US" sz="2400" b="0" dirty="0">
+              <a:rPr lang="en-US" sz="2000" b="0" dirty="0">
                 <a:solidFill>
                   <a:srgbClr val="008000"/>
                 </a:solidFill>
@@ -21888,7 +21775,7 @@
               </a:rPr>
               <a:t>// promise is rejected if id invalid</a:t>
             </a:r>
-            <a:endParaRPr lang="en-US" sz="2400" b="0" dirty="0">
+            <a:endParaRPr lang="en-US" sz="2000" b="0" dirty="0">
               <a:solidFill>
                 <a:srgbClr val="3B3B3B"/>
               </a:solidFill>
@@ -21901,7 +21788,7 @@
               <a:buNone/>
             </a:pPr>
             <a:r>
-              <a:rPr lang="en-US" sz="2400" b="0" dirty="0">
+              <a:rPr lang="en-US" sz="2000" b="0" dirty="0">
                 <a:solidFill>
                   <a:srgbClr val="3B3B3B"/>
                 </a:solidFill>
@@ -21911,7 +21798,7 @@
               <a:t>  </a:t>
             </a:r>
             <a:r>
-              <a:rPr lang="en-US" sz="2400" b="0" dirty="0" err="1">
+              <a:rPr lang="en-US" sz="2000" b="0" dirty="0" err="1">
                 <a:solidFill>
                   <a:srgbClr val="795E26"/>
                 </a:solidFill>
@@ -21921,7 +21808,7 @@
               <a:t>addGrade</a:t>
             </a:r>
             <a:r>
-              <a:rPr lang="en-US" sz="2400" b="0" dirty="0">
+              <a:rPr lang="en-US" sz="2000" b="0" dirty="0">
                 <a:solidFill>
                   <a:srgbClr val="3B3B3B"/>
                 </a:solidFill>
@@ -21931,7 +21818,7 @@
               <a:t>(</a:t>
             </a:r>
             <a:r>
-              <a:rPr lang="en-US" sz="2400" b="0" dirty="0">
+              <a:rPr lang="en-US" sz="2000" b="0" dirty="0">
                 <a:solidFill>
                   <a:srgbClr val="001080"/>
                 </a:solidFill>
@@ -21941,7 +21828,7 @@
               <a:t>id</a:t>
             </a:r>
             <a:r>
-              <a:rPr lang="en-US" sz="2400" b="0" dirty="0">
+              <a:rPr lang="en-US" sz="2000" b="0" dirty="0">
                 <a:solidFill>
                   <a:srgbClr val="000000"/>
                 </a:solidFill>
@@ -21951,7 +21838,7 @@
               <a:t>:</a:t>
             </a:r>
             <a:r>
-              <a:rPr lang="en-US" sz="2400" b="0" dirty="0">
+              <a:rPr lang="en-US" sz="2000" b="0" dirty="0">
                 <a:solidFill>
                   <a:srgbClr val="3B3B3B"/>
                 </a:solidFill>
@@ -21961,7 +21848,7 @@
               <a:t> </a:t>
             </a:r>
             <a:r>
-              <a:rPr lang="en-US" sz="2400" b="0" dirty="0" err="1">
+              <a:rPr lang="en-US" sz="2000" b="0" dirty="0" err="1">
                 <a:solidFill>
                   <a:srgbClr val="267F99"/>
                 </a:solidFill>
@@ -21971,7 +21858,7 @@
               <a:t>StudentID</a:t>
             </a:r>
             <a:r>
-              <a:rPr lang="en-US" sz="2400" b="0" dirty="0">
+              <a:rPr lang="en-US" sz="2000" b="0" dirty="0">
                 <a:solidFill>
                   <a:srgbClr val="3B3B3B"/>
                 </a:solidFill>
@@ -21981,7 +21868,7 @@
               <a:t>, </a:t>
             </a:r>
             <a:r>
-              <a:rPr lang="en-US" sz="2400" b="0" dirty="0">
+              <a:rPr lang="en-US" sz="2000" b="0" dirty="0">
                 <a:solidFill>
                   <a:srgbClr val="001080"/>
                 </a:solidFill>
@@ -21991,7 +21878,7 @@
               <a:t>course</a:t>
             </a:r>
             <a:r>
-              <a:rPr lang="en-US" sz="2400" b="0" dirty="0">
+              <a:rPr lang="en-US" sz="2000" b="0" dirty="0">
                 <a:solidFill>
                   <a:srgbClr val="000000"/>
                 </a:solidFill>
@@ -22001,7 +21888,7 @@
               <a:t>:</a:t>
             </a:r>
             <a:r>
-              <a:rPr lang="en-US" sz="2400" b="0" dirty="0">
+              <a:rPr lang="en-US" sz="2000" b="0" dirty="0">
                 <a:solidFill>
                   <a:srgbClr val="3B3B3B"/>
                 </a:solidFill>
@@ -22011,7 +21898,7 @@
               <a:t> </a:t>
             </a:r>
             <a:r>
-              <a:rPr lang="en-US" sz="2400" b="0" dirty="0">
+              <a:rPr lang="en-US" sz="2000" b="0" dirty="0">
                 <a:solidFill>
                   <a:srgbClr val="267F99"/>
                 </a:solidFill>
@@ -22021,7 +21908,7 @@
               <a:t>Course</a:t>
             </a:r>
             <a:r>
-              <a:rPr lang="en-US" sz="2400" b="0" dirty="0">
+              <a:rPr lang="en-US" sz="2000" b="0" dirty="0">
                 <a:solidFill>
                   <a:srgbClr val="3B3B3B"/>
                 </a:solidFill>
@@ -22031,7 +21918,7 @@
               <a:t>, </a:t>
             </a:r>
             <a:r>
-              <a:rPr lang="en-US" sz="2400" b="0" dirty="0" err="1">
+              <a:rPr lang="en-US" sz="2000" b="0" dirty="0" err="1">
                 <a:solidFill>
                   <a:srgbClr val="001080"/>
                 </a:solidFill>
@@ -22041,7 +21928,7 @@
               <a:t>courseGrade</a:t>
             </a:r>
             <a:r>
-              <a:rPr lang="en-US" sz="2400" b="0" dirty="0">
+              <a:rPr lang="en-US" sz="2000" b="0" dirty="0">
                 <a:solidFill>
                   <a:srgbClr val="000000"/>
                 </a:solidFill>
@@ -22051,7 +21938,7 @@
               <a:t>:</a:t>
             </a:r>
             <a:r>
-              <a:rPr lang="en-US" sz="2400" b="0" dirty="0">
+              <a:rPr lang="en-US" sz="2000" b="0" dirty="0">
                 <a:solidFill>
                   <a:srgbClr val="3B3B3B"/>
                 </a:solidFill>
@@ -22061,7 +21948,7 @@
               <a:t> </a:t>
             </a:r>
             <a:r>
-              <a:rPr lang="en-US" sz="2400" b="0" dirty="0" err="1">
+              <a:rPr lang="en-US" sz="2000" b="0" dirty="0" err="1">
                 <a:solidFill>
                   <a:srgbClr val="267F99"/>
                 </a:solidFill>
@@ -22071,7 +21958,7 @@
               <a:t>CourseGrade</a:t>
             </a:r>
             <a:r>
-              <a:rPr lang="en-US" sz="2400" b="0" dirty="0">
+              <a:rPr lang="en-US" sz="2000" b="0" dirty="0">
                 <a:solidFill>
                   <a:srgbClr val="3B3B3B"/>
                 </a:solidFill>
@@ -22081,7 +21968,7 @@
               <a:t>)</a:t>
             </a:r>
             <a:r>
-              <a:rPr lang="en-US" sz="2400" b="0" dirty="0">
+              <a:rPr lang="en-US" sz="2000" b="0" dirty="0">
                 <a:solidFill>
                   <a:srgbClr val="000000"/>
                 </a:solidFill>
@@ -22096,7 +21983,7 @@
               <a:buNone/>
             </a:pPr>
             <a:r>
-              <a:rPr lang="en-US" sz="2400" dirty="0">
+              <a:rPr lang="en-US" sz="2000" dirty="0">
                 <a:solidFill>
                   <a:srgbClr val="000000"/>
                 </a:solidFill>
@@ -22105,7 +21992,7 @@
               <a:t>    </a:t>
             </a:r>
             <a:r>
-              <a:rPr lang="en-US" sz="2400" b="0" dirty="0">
+              <a:rPr lang="en-US" sz="2000" b="0" dirty="0">
                 <a:solidFill>
                   <a:srgbClr val="3B3B3B"/>
                 </a:solidFill>
@@ -22115,7 +22002,7 @@
               <a:t> </a:t>
             </a:r>
             <a:r>
-              <a:rPr lang="en-US" sz="2400" b="1" dirty="0">
+              <a:rPr lang="en-US" sz="2000" b="1" dirty="0">
                 <a:solidFill>
                   <a:srgbClr val="267F99"/>
                 </a:solidFill>
@@ -22125,7 +22012,7 @@
               <a:t>Promise</a:t>
             </a:r>
             <a:r>
-              <a:rPr lang="en-US" sz="2400" b="0" dirty="0">
+              <a:rPr lang="en-US" sz="2000" b="0" dirty="0">
                 <a:solidFill>
                   <a:srgbClr val="3B3B3B"/>
                 </a:solidFill>
@@ -22135,7 +22022,7 @@
               <a:t>&lt;</a:t>
             </a:r>
             <a:r>
-              <a:rPr lang="en-US" sz="2400" b="0" dirty="0">
+              <a:rPr lang="en-US" sz="2000" b="0" dirty="0">
                 <a:solidFill>
                   <a:srgbClr val="267F99"/>
                 </a:solidFill>
@@ -22145,7 +22032,7 @@
               <a:t>void</a:t>
             </a:r>
             <a:r>
-              <a:rPr lang="en-US" sz="2400" b="0" dirty="0">
+              <a:rPr lang="en-US" sz="2000" b="0" dirty="0">
                 <a:solidFill>
                   <a:srgbClr val="3B3B3B"/>
                 </a:solidFill>
@@ -22160,7 +22047,7 @@
               <a:buNone/>
             </a:pPr>
             <a:r>
-              <a:rPr lang="en-US" sz="2400" b="0" dirty="0">
+              <a:rPr lang="en-US" sz="2000" b="0" dirty="0">
                 <a:solidFill>
                   <a:srgbClr val="3B3B3B"/>
                 </a:solidFill>
@@ -22170,7 +22057,7 @@
               <a:t>  </a:t>
             </a:r>
             <a:r>
-              <a:rPr lang="en-US" sz="2400" b="0" dirty="0" err="1">
+              <a:rPr lang="en-US" sz="2000" b="0" dirty="0" err="1">
                 <a:solidFill>
                   <a:srgbClr val="795E26"/>
                 </a:solidFill>
@@ -22180,7 +22067,7 @@
               <a:t>getGrade</a:t>
             </a:r>
             <a:r>
-              <a:rPr lang="en-US" sz="2400" b="0" dirty="0">
+              <a:rPr lang="en-US" sz="2000" b="0" dirty="0">
                 <a:solidFill>
                   <a:srgbClr val="3B3B3B"/>
                 </a:solidFill>
@@ -22190,7 +22077,7 @@
               <a:t>(</a:t>
             </a:r>
             <a:r>
-              <a:rPr lang="en-US" sz="2400" b="0" dirty="0">
+              <a:rPr lang="en-US" sz="2000" b="0" dirty="0">
                 <a:solidFill>
                   <a:srgbClr val="001080"/>
                 </a:solidFill>
@@ -22200,7 +22087,7 @@
               <a:t>id</a:t>
             </a:r>
             <a:r>
-              <a:rPr lang="en-US" sz="2400" b="0" dirty="0">
+              <a:rPr lang="en-US" sz="2000" b="0" dirty="0">
                 <a:solidFill>
                   <a:srgbClr val="000000"/>
                 </a:solidFill>
@@ -22210,7 +22097,7 @@
               <a:t>:</a:t>
             </a:r>
             <a:r>
-              <a:rPr lang="en-US" sz="2400" b="0" dirty="0">
+              <a:rPr lang="en-US" sz="2000" b="0" dirty="0">
                 <a:solidFill>
                   <a:srgbClr val="3B3B3B"/>
                 </a:solidFill>
@@ -22220,7 +22107,7 @@
               <a:t> </a:t>
             </a:r>
             <a:r>
-              <a:rPr lang="en-US" sz="2400" b="0" dirty="0" err="1">
+              <a:rPr lang="en-US" sz="2000" b="0" dirty="0" err="1">
                 <a:solidFill>
                   <a:srgbClr val="267F99"/>
                 </a:solidFill>
@@ -22230,7 +22117,7 @@
               <a:t>StudentID</a:t>
             </a:r>
             <a:r>
-              <a:rPr lang="en-US" sz="2400" b="0" dirty="0">
+              <a:rPr lang="en-US" sz="2000" b="0" dirty="0">
                 <a:solidFill>
                   <a:srgbClr val="3B3B3B"/>
                 </a:solidFill>
@@ -22240,7 +22127,7 @@
               <a:t>, </a:t>
             </a:r>
             <a:r>
-              <a:rPr lang="en-US" sz="2400" b="0" dirty="0">
+              <a:rPr lang="en-US" sz="2000" b="0" dirty="0">
                 <a:solidFill>
                   <a:srgbClr val="001080"/>
                 </a:solidFill>
@@ -22250,7 +22137,7 @@
               <a:t>course</a:t>
             </a:r>
             <a:r>
-              <a:rPr lang="en-US" sz="2400" b="0" dirty="0">
+              <a:rPr lang="en-US" sz="2000" b="0" dirty="0">
                 <a:solidFill>
                   <a:srgbClr val="000000"/>
                 </a:solidFill>
@@ -22260,7 +22147,7 @@
               <a:t>:</a:t>
             </a:r>
             <a:r>
-              <a:rPr lang="en-US" sz="2400" b="0" dirty="0">
+              <a:rPr lang="en-US" sz="2000" b="0" dirty="0">
                 <a:solidFill>
                   <a:srgbClr val="3B3B3B"/>
                 </a:solidFill>
@@ -22270,7 +22157,7 @@
               <a:t> </a:t>
             </a:r>
             <a:r>
-              <a:rPr lang="en-US" sz="2400" b="0" dirty="0">
+              <a:rPr lang="en-US" sz="2000" b="0" dirty="0">
                 <a:solidFill>
                   <a:srgbClr val="267F99"/>
                 </a:solidFill>
@@ -22280,7 +22167,7 @@
               <a:t>Course</a:t>
             </a:r>
             <a:r>
-              <a:rPr lang="en-US" sz="2400" b="0" dirty="0">
+              <a:rPr lang="en-US" sz="2000" b="0" dirty="0">
                 <a:solidFill>
                   <a:srgbClr val="3B3B3B"/>
                 </a:solidFill>
@@ -22290,7 +22177,7 @@
               <a:t>)</a:t>
             </a:r>
             <a:r>
-              <a:rPr lang="en-US" sz="2400" b="0" dirty="0">
+              <a:rPr lang="en-US" sz="2000" b="0" dirty="0">
                 <a:solidFill>
                   <a:srgbClr val="000000"/>
                 </a:solidFill>
@@ -22300,7 +22187,7 @@
               <a:t>:</a:t>
             </a:r>
             <a:r>
-              <a:rPr lang="en-US" sz="2400" b="0" dirty="0">
+              <a:rPr lang="en-US" sz="2000" b="0" dirty="0">
                 <a:solidFill>
                   <a:srgbClr val="3B3B3B"/>
                 </a:solidFill>
@@ -22310,7 +22197,7 @@
               <a:t> </a:t>
             </a:r>
             <a:r>
-              <a:rPr lang="en-US" sz="2400" b="0" dirty="0">
+              <a:rPr lang="en-US" sz="2000" b="0" dirty="0">
                 <a:solidFill>
                   <a:srgbClr val="267F99"/>
                 </a:solidFill>
@@ -22323,7 +22210,7 @@
               <a:t>Promise</a:t>
             </a:r>
             <a:r>
-              <a:rPr lang="en-US" sz="2400" b="0" dirty="0">
+              <a:rPr lang="en-US" sz="2000" b="0" dirty="0">
                 <a:solidFill>
                   <a:srgbClr val="3B3B3B"/>
                 </a:solidFill>
@@ -22333,7 +22220,7 @@
               <a:t>&lt;</a:t>
             </a:r>
             <a:r>
-              <a:rPr lang="en-US" sz="2400" b="0" dirty="0" err="1">
+              <a:rPr lang="en-US" sz="2000" b="0" dirty="0" err="1">
                 <a:solidFill>
                   <a:srgbClr val="267F99"/>
                 </a:solidFill>
@@ -22343,7 +22230,7 @@
               <a:t>CourseGrade</a:t>
             </a:r>
             <a:r>
-              <a:rPr lang="en-US" sz="2400" b="0" dirty="0">
+              <a:rPr lang="en-US" sz="2000" b="0" dirty="0">
                 <a:solidFill>
                   <a:srgbClr val="3B3B3B"/>
                 </a:solidFill>
@@ -22358,7 +22245,7 @@
               <a:buNone/>
             </a:pPr>
             <a:r>
-              <a:rPr lang="en-US" sz="2400" b="0" dirty="0">
+              <a:rPr lang="en-US" sz="2000" b="0" dirty="0">
                 <a:solidFill>
                   <a:srgbClr val="3B3B3B"/>
                 </a:solidFill>
@@ -22368,7 +22255,7 @@
               <a:t>  </a:t>
             </a:r>
             <a:r>
-              <a:rPr lang="en-US" sz="2400" b="0" dirty="0" err="1">
+              <a:rPr lang="en-US" sz="2000" b="0" dirty="0" err="1">
                 <a:solidFill>
                   <a:srgbClr val="795E26"/>
                 </a:solidFill>
@@ -22378,7 +22265,7 @@
               <a:t>nameToIDs</a:t>
             </a:r>
             <a:r>
-              <a:rPr lang="en-US" sz="2400" b="0" dirty="0">
+              <a:rPr lang="en-US" sz="2000" b="0" dirty="0">
                 <a:solidFill>
                   <a:srgbClr val="3B3B3B"/>
                 </a:solidFill>
@@ -22388,7 +22275,7 @@
               <a:t>(</a:t>
             </a:r>
             <a:r>
-              <a:rPr lang="en-US" sz="2400" b="0" dirty="0" err="1">
+              <a:rPr lang="en-US" sz="2000" b="0" dirty="0" err="1">
                 <a:solidFill>
                   <a:srgbClr val="001080"/>
                 </a:solidFill>
@@ -22398,7 +22285,7 @@
               <a:t>studentName</a:t>
             </a:r>
             <a:r>
-              <a:rPr lang="en-US" sz="2400" b="0" dirty="0">
+              <a:rPr lang="en-US" sz="2000" b="0" dirty="0">
                 <a:solidFill>
                   <a:srgbClr val="000000"/>
                 </a:solidFill>
@@ -22408,7 +22295,7 @@
               <a:t>:</a:t>
             </a:r>
             <a:r>
-              <a:rPr lang="en-US" sz="2400" b="0" dirty="0">
+              <a:rPr lang="en-US" sz="2000" b="0" dirty="0">
                 <a:solidFill>
                   <a:srgbClr val="3B3B3B"/>
                 </a:solidFill>
@@ -22418,7 +22305,7 @@
               <a:t> </a:t>
             </a:r>
             <a:r>
-              <a:rPr lang="en-US" sz="2400" b="0" dirty="0">
+              <a:rPr lang="en-US" sz="2000" b="0" dirty="0">
                 <a:solidFill>
                   <a:srgbClr val="267F99"/>
                 </a:solidFill>
@@ -22428,7 +22315,7 @@
               <a:t>string</a:t>
             </a:r>
             <a:r>
-              <a:rPr lang="en-US" sz="2400" b="0" dirty="0">
+              <a:rPr lang="en-US" sz="2000" b="0" dirty="0">
                 <a:solidFill>
                   <a:srgbClr val="3B3B3B"/>
                 </a:solidFill>
@@ -22438,7 +22325,7 @@
               <a:t>)</a:t>
             </a:r>
             <a:r>
-              <a:rPr lang="en-US" sz="2400" b="0" dirty="0">
+              <a:rPr lang="en-US" sz="2000" b="0" dirty="0">
                 <a:solidFill>
                   <a:srgbClr val="000000"/>
                 </a:solidFill>
@@ -22448,7 +22335,7 @@
               <a:t>:</a:t>
             </a:r>
             <a:r>
-              <a:rPr lang="en-US" sz="2400" b="0" dirty="0">
+              <a:rPr lang="en-US" sz="2000" b="0" dirty="0">
                 <a:solidFill>
                   <a:srgbClr val="3B3B3B"/>
                 </a:solidFill>
@@ -22458,7 +22345,7 @@
               <a:t> </a:t>
             </a:r>
             <a:r>
-              <a:rPr lang="en-US" sz="2400" b="0" dirty="0">
+              <a:rPr lang="en-US" sz="2000" b="0" dirty="0">
                 <a:solidFill>
                   <a:srgbClr val="267F99"/>
                 </a:solidFill>
@@ -22471,7 +22358,7 @@
               <a:t>Promise</a:t>
             </a:r>
             <a:r>
-              <a:rPr lang="en-US" sz="2400" b="0" dirty="0">
+              <a:rPr lang="en-US" sz="2000" b="0" dirty="0">
                 <a:solidFill>
                   <a:srgbClr val="3B3B3B"/>
                 </a:solidFill>
@@ -22481,7 +22368,7 @@
               <a:t>&lt;</a:t>
             </a:r>
             <a:r>
-              <a:rPr lang="en-US" sz="2400" b="0" dirty="0" err="1">
+              <a:rPr lang="en-US" sz="2000" b="0" dirty="0" err="1">
                 <a:solidFill>
                   <a:srgbClr val="267F99"/>
                 </a:solidFill>
@@ -22491,7 +22378,7 @@
               <a:t>StudentID</a:t>
             </a:r>
             <a:r>
-              <a:rPr lang="en-US" sz="2400" b="0" dirty="0">
+              <a:rPr lang="en-US" sz="2000" b="0" dirty="0">
                 <a:solidFill>
                   <a:srgbClr val="3B3B3B"/>
                 </a:solidFill>
@@ -22506,7 +22393,7 @@
               <a:buNone/>
             </a:pPr>
             <a:r>
-              <a:rPr lang="en-US" sz="2400" dirty="0">
+              <a:rPr lang="en-US" sz="2000" dirty="0">
                 <a:solidFill>
                   <a:srgbClr val="3B3B3B"/>
                 </a:solidFill>
@@ -22514,7 +22401,7 @@
               </a:rPr>
               <a:t>}</a:t>
             </a:r>
-            <a:endParaRPr lang="en-US" sz="2400" b="0" dirty="0">
+            <a:endParaRPr lang="en-US" sz="2000" b="0" dirty="0">
               <a:solidFill>
                 <a:srgbClr val="3B3B3B"/>
               </a:solidFill>
@@ -22537,7 +22424,7 @@
 </p:sld>
 </file>
 
-<file path=ppt/slides/slide25.xml><?xml version="1.0" encoding="utf-8"?>
+<file path=ppt/slides/slide24.xml><?xml version="1.0" encoding="utf-8"?>
 <p:sld xmlns:a="http://schemas.openxmlformats.org/drawingml/2006/main" xmlns:r="http://schemas.openxmlformats.org/officeDocument/2006/relationships" xmlns:p="http://schemas.openxmlformats.org/presentationml/2006/main">
   <p:cSld>
     <p:spTree>
@@ -22658,7 +22545,7 @@
           <a:p>
             <a:fld id="{20F37917-FD3A-4669-9018-DA04BCDD3D75}" type="slidenum">
               <a:rPr lang="en-US" smtClean="0"/>
-              <a:t>25</a:t>
+              <a:t>24</a:t>
             </a:fld>
             <a:endParaRPr lang="en-US"/>
           </a:p>
@@ -23460,7 +23347,7 @@
 </p:sld>
 </file>
 
-<file path=ppt/slides/slide26.xml><?xml version="1.0" encoding="utf-8"?>
+<file path=ppt/slides/slide25.xml><?xml version="1.0" encoding="utf-8"?>
 <p:sld xmlns:a="http://schemas.openxmlformats.org/drawingml/2006/main" xmlns:r="http://schemas.openxmlformats.org/officeDocument/2006/relationships" xmlns:p="http://schemas.openxmlformats.org/presentationml/2006/main">
   <p:cSld>
     <p:spTree>
@@ -23542,7 +23429,7 @@
           <a:p>
             <a:fld id="{20F37917-FD3A-4669-9018-DA04BCDD3D75}" type="slidenum">
               <a:rPr lang="en-US" smtClean="0"/>
-              <a:t>26</a:t>
+              <a:t>25</a:t>
             </a:fld>
             <a:endParaRPr lang="en-US"/>
           </a:p>
@@ -24340,13 +24227,13 @@
         </p:nvSpPr>
         <p:spPr>
           <a:xfrm>
-            <a:off x="472238" y="4635587"/>
-            <a:ext cx="7887346" cy="1483672"/>
+            <a:off x="472237" y="4635587"/>
+            <a:ext cx="8528543" cy="1483672"/>
           </a:xfrm>
         </p:spPr>
         <p:txBody>
           <a:bodyPr>
-            <a:normAutofit fontScale="85000" lnSpcReduction="20000"/>
+            <a:normAutofit fontScale="85000" lnSpcReduction="10000"/>
           </a:bodyPr>
           <a:lstStyle/>
           <a:p>
@@ -24376,7 +24263,7 @@
 </p:sld>
 </file>
 
-<file path=ppt/slides/slide27.xml><?xml version="1.0" encoding="utf-8"?>
+<file path=ppt/slides/slide26.xml><?xml version="1.0" encoding="utf-8"?>
 <p:sld xmlns:a="http://schemas.openxmlformats.org/drawingml/2006/main" xmlns:r="http://schemas.openxmlformats.org/officeDocument/2006/relationships" xmlns:p="http://schemas.openxmlformats.org/presentationml/2006/main">
   <p:cSld>
     <p:spTree>
@@ -24440,7 +24327,7 @@
         <p:spPr>
           <a:xfrm>
             <a:off x="838200" y="3828690"/>
-            <a:ext cx="7887346" cy="2800710"/>
+            <a:ext cx="9782060" cy="2800710"/>
           </a:xfrm>
         </p:spPr>
         <p:txBody>
@@ -24502,7 +24389,7 @@
           <a:p>
             <a:fld id="{20F37917-FD3A-4669-9018-DA04BCDD3D75}" type="slidenum">
               <a:rPr lang="en-US" smtClean="0"/>
-              <a:t>27</a:t>
+              <a:t>26</a:t>
             </a:fld>
             <a:endParaRPr lang="en-US"/>
           </a:p>
@@ -24982,7 +24869,7 @@
 </p:sld>
 </file>
 
-<file path=ppt/slides/slide28.xml><?xml version="1.0" encoding="utf-8"?>
+<file path=ppt/slides/slide27.xml><?xml version="1.0" encoding="utf-8"?>
 <p:sld xmlns:a="http://schemas.openxmlformats.org/drawingml/2006/main" xmlns:r="http://schemas.openxmlformats.org/officeDocument/2006/relationships" xmlns:p="http://schemas.openxmlformats.org/presentationml/2006/main" show="0">
   <p:cSld>
     <p:spTree>
@@ -25098,7 +24985,7 @@
           <a:p>
             <a:fld id="{20F37917-FD3A-4669-9018-DA04BCDD3D75}" type="slidenum">
               <a:rPr lang="en-US" smtClean="0"/>
-              <a:t>28</a:t>
+              <a:t>27</a:t>
             </a:fld>
             <a:endParaRPr lang="en-US"/>
           </a:p>
@@ -25443,7 +25330,7 @@
 </p:sld>
 </file>
 
-<file path=ppt/slides/slide29.xml><?xml version="1.0" encoding="utf-8"?>
+<file path=ppt/slides/slide28.xml><?xml version="1.0" encoding="utf-8"?>
 <p:sld xmlns:a="http://schemas.openxmlformats.org/drawingml/2006/main" xmlns:r="http://schemas.openxmlformats.org/officeDocument/2006/relationships" xmlns:p="http://schemas.openxmlformats.org/presentationml/2006/main">
   <p:cSld>
     <p:spTree>
@@ -25566,7 +25453,7 @@
                 <a:tabLst/>
                 <a:defRPr/>
               </a:pPr>
-              <a:t>29</a:t>
+              <a:t>28</a:t>
             </a:fld>
             <a:endParaRPr kumimoji="0" lang="en-US" sz="1200" b="0" i="0" u="none" strike="noStrike" kern="1200" cap="none" spc="0" normalizeH="0" baseline="0" noProof="0">
               <a:ln>

</xml_diff>

<commit_message>
corrected refs to code
</commit_message>
<xml_diff>
--- a/Slides/Module 04 Web Application Architecture.pptx
+++ b/Slides/Module 04 Web Application Architecture.pptx
@@ -204,7 +204,7 @@
 <file path=ppt/revisionInfo.xml><?xml version="1.0" encoding="utf-8"?>
 <p1510:revInfo xmlns:a="http://schemas.openxmlformats.org/drawingml/2006/main" xmlns:r="http://schemas.openxmlformats.org/officeDocument/2006/relationships" xmlns:p1510="http://schemas.microsoft.com/office/powerpoint/2015/10/main">
   <p1510:revLst>
-    <p1510:client id="{7985E36C-082E-4D27-87D0-546C154619B6}" v="232" dt="2026-09-03T17:04:24.375"/>
+    <p1510:client id="{B99AE313-F5B2-4D90-9436-99EB28C5AF1E}" v="1" dt="2026-09-09T17:11:26.622"/>
   </p1510:revLst>
 </p1510:revInfo>
 </file>
@@ -214,38 +214,24 @@
   <pc:docChgLst>
     <pc:chgData name="Mitchell Wand" userId="de9b44c55c049659" providerId="LiveId" clId="{7A9D5940-B2CC-47DD-AF5E-71219F1A1E26}"/>
     <pc:docChg chg="undo custSel addSld delSld modSld sldOrd modSection">
-      <pc:chgData name="Mitchell Wand" userId="de9b44c55c049659" providerId="LiveId" clId="{7A9D5940-B2CC-47DD-AF5E-71219F1A1E26}" dt="2026-09-03T17:49:43.910" v="2217" actId="20577"/>
+      <pc:chgData name="Mitchell Wand" userId="de9b44c55c049659" providerId="LiveId" clId="{7A9D5940-B2CC-47DD-AF5E-71219F1A1E26}" dt="2026-09-09T20:00:11.644" v="3586" actId="20577"/>
       <pc:docMkLst>
         <pc:docMk/>
       </pc:docMkLst>
-      <pc:sldChg chg="add del">
-        <pc:chgData name="Mitchell Wand" userId="de9b44c55c049659" providerId="LiveId" clId="{7A9D5940-B2CC-47DD-AF5E-71219F1A1E26}" dt="2026-09-03T16:47:54.852" v="1134" actId="2696"/>
-        <pc:sldMkLst>
-          <pc:docMk/>
-          <pc:sldMk cId="1100294374" sldId="544"/>
-        </pc:sldMkLst>
-      </pc:sldChg>
       <pc:sldChg chg="modSp mod">
-        <pc:chgData name="Mitchell Wand" userId="de9b44c55c049659" providerId="LiveId" clId="{7A9D5940-B2CC-47DD-AF5E-71219F1A1E26}" dt="2026-09-03T17:04:11.406" v="1776" actId="21"/>
+        <pc:chgData name="Mitchell Wand" userId="de9b44c55c049659" providerId="LiveId" clId="{7A9D5940-B2CC-47DD-AF5E-71219F1A1E26}" dt="2026-09-09T17:11:26.622" v="2219"/>
         <pc:sldMkLst>
           <pc:docMk/>
           <pc:sldMk cId="3241157687" sldId="720"/>
         </pc:sldMkLst>
         <pc:spChg chg="mod">
-          <ac:chgData name="Mitchell Wand" userId="de9b44c55c049659" providerId="LiveId" clId="{7A9D5940-B2CC-47DD-AF5E-71219F1A1E26}" dt="2026-09-03T17:04:11.406" v="1776" actId="21"/>
+          <ac:chgData name="Mitchell Wand" userId="de9b44c55c049659" providerId="LiveId" clId="{7A9D5940-B2CC-47DD-AF5E-71219F1A1E26}" dt="2026-09-09T17:11:26.622" v="2219"/>
           <ac:spMkLst>
             <pc:docMk/>
             <pc:sldMk cId="3241157687" sldId="720"/>
             <ac:spMk id="3" creationId="{336CA7E9-7931-8287-2782-8D75B63B3AE8}"/>
           </ac:spMkLst>
         </pc:spChg>
-      </pc:sldChg>
-      <pc:sldChg chg="del mod modShow">
-        <pc:chgData name="Mitchell Wand" userId="de9b44c55c049659" providerId="LiveId" clId="{7A9D5940-B2CC-47DD-AF5E-71219F1A1E26}" dt="2026-09-03T16:49:39.681" v="1156" actId="2696"/>
-        <pc:sldMkLst>
-          <pc:docMk/>
-          <pc:sldMk cId="855630791" sldId="726"/>
-        </pc:sldMkLst>
       </pc:sldChg>
       <pc:sldChg chg="modSp mod ord">
         <pc:chgData name="Mitchell Wand" userId="de9b44c55c049659" providerId="LiveId" clId="{7A9D5940-B2CC-47DD-AF5E-71219F1A1E26}" dt="2026-09-03T17:00:18.479" v="1593" actId="20577"/>
@@ -285,13 +271,6 @@
           </ac:spMkLst>
         </pc:spChg>
       </pc:sldChg>
-      <pc:sldChg chg="del">
-        <pc:chgData name="Mitchell Wand" userId="de9b44c55c049659" providerId="LiveId" clId="{7A9D5940-B2CC-47DD-AF5E-71219F1A1E26}" dt="2026-09-03T16:26:05.317" v="716" actId="2696"/>
-        <pc:sldMkLst>
-          <pc:docMk/>
-          <pc:sldMk cId="1273063621" sldId="756"/>
-        </pc:sldMkLst>
-      </pc:sldChg>
       <pc:sldChg chg="addSp delSp modSp mod delAnim">
         <pc:chgData name="Mitchell Wand" userId="de9b44c55c049659" providerId="LiveId" clId="{7A9D5940-B2CC-47DD-AF5E-71219F1A1E26}" dt="2026-09-03T16:30:35.525" v="755" actId="20577"/>
         <pc:sldMkLst>
@@ -306,38 +285,6 @@
             <ac:spMk id="2" creationId="{1F0081C9-3D16-98CF-B12F-34FDBDB20DF7}"/>
           </ac:spMkLst>
         </pc:spChg>
-        <pc:spChg chg="del">
-          <ac:chgData name="Mitchell Wand" userId="de9b44c55c049659" providerId="LiveId" clId="{7A9D5940-B2CC-47DD-AF5E-71219F1A1E26}" dt="2026-09-03T16:26:39.273" v="717" actId="478"/>
-          <ac:spMkLst>
-            <pc:docMk/>
-            <pc:sldMk cId="2989267207" sldId="757"/>
-            <ac:spMk id="3" creationId="{D8861E4B-9414-E778-C916-4DD92A306003}"/>
-          </ac:spMkLst>
-        </pc:spChg>
-        <pc:spChg chg="del mod">
-          <ac:chgData name="Mitchell Wand" userId="de9b44c55c049659" providerId="LiveId" clId="{7A9D5940-B2CC-47DD-AF5E-71219F1A1E26}" dt="2026-09-03T16:27:00.417" v="723" actId="478"/>
-          <ac:spMkLst>
-            <pc:docMk/>
-            <pc:sldMk cId="2989267207" sldId="757"/>
-            <ac:spMk id="5" creationId="{44A27ADD-0A3B-E7B8-77AC-E285247C50E3}"/>
-          </ac:spMkLst>
-        </pc:spChg>
-        <pc:spChg chg="del mod">
-          <ac:chgData name="Mitchell Wand" userId="de9b44c55c049659" providerId="LiveId" clId="{7A9D5940-B2CC-47DD-AF5E-71219F1A1E26}" dt="2026-09-03T16:26:56.872" v="721" actId="478"/>
-          <ac:spMkLst>
-            <pc:docMk/>
-            <pc:sldMk cId="2989267207" sldId="757"/>
-            <ac:spMk id="7" creationId="{6EA6D935-4A83-C5F5-C96F-D27AF013E8FD}"/>
-          </ac:spMkLst>
-        </pc:spChg>
-        <pc:spChg chg="add del mod">
-          <ac:chgData name="Mitchell Wand" userId="de9b44c55c049659" providerId="LiveId" clId="{7A9D5940-B2CC-47DD-AF5E-71219F1A1E26}" dt="2026-09-03T16:26:47.746" v="718" actId="478"/>
-          <ac:spMkLst>
-            <pc:docMk/>
-            <pc:sldMk cId="2989267207" sldId="757"/>
-            <ac:spMk id="9" creationId="{9BFE8434-D0E4-9662-6569-1DF2169A6BAC}"/>
-          </ac:spMkLst>
-        </pc:spChg>
         <pc:spChg chg="add mod">
           <ac:chgData name="Mitchell Wand" userId="de9b44c55c049659" providerId="LiveId" clId="{7A9D5940-B2CC-47DD-AF5E-71219F1A1E26}" dt="2026-09-03T16:29:02.690" v="745" actId="1076"/>
           <ac:spMkLst>
@@ -346,22 +293,6 @@
             <ac:spMk id="13" creationId="{723C29A3-CDE7-6687-B80E-5CE6AD1F9B77}"/>
           </ac:spMkLst>
         </pc:spChg>
-        <pc:spChg chg="del">
-          <ac:chgData name="Mitchell Wand" userId="de9b44c55c049659" providerId="LiveId" clId="{7A9D5940-B2CC-47DD-AF5E-71219F1A1E26}" dt="2026-09-03T16:26:53.999" v="719" actId="478"/>
-          <ac:spMkLst>
-            <pc:docMk/>
-            <pc:sldMk cId="2989267207" sldId="757"/>
-            <ac:spMk id="31" creationId="{6734EAB7-52B9-D9B9-FE5C-6604B1F64EF3}"/>
-          </ac:spMkLst>
-        </pc:spChg>
-        <pc:picChg chg="add del">
-          <ac:chgData name="Mitchell Wand" userId="de9b44c55c049659" providerId="LiveId" clId="{7A9D5940-B2CC-47DD-AF5E-71219F1A1E26}" dt="2026-09-03T16:27:34.099" v="725" actId="478"/>
-          <ac:picMkLst>
-            <pc:docMk/>
-            <pc:sldMk cId="2989267207" sldId="757"/>
-            <ac:picMk id="11" creationId="{2CC1BD3B-EF11-012F-7878-E9703432C6D4}"/>
-          </ac:picMkLst>
-        </pc:picChg>
       </pc:sldChg>
       <pc:sldChg chg="modSp mod">
         <pc:chgData name="Mitchell Wand" userId="de9b44c55c049659" providerId="LiveId" clId="{7A9D5940-B2CC-47DD-AF5E-71219F1A1E26}" dt="2026-09-03T16:46:29.667" v="1120" actId="20577"/>
@@ -393,13 +324,6 @@
           </ac:spMkLst>
         </pc:spChg>
       </pc:sldChg>
-      <pc:sldChg chg="del mod modShow">
-        <pc:chgData name="Mitchell Wand" userId="de9b44c55c049659" providerId="LiveId" clId="{7A9D5940-B2CC-47DD-AF5E-71219F1A1E26}" dt="2026-09-03T16:48:44.169" v="1135" actId="2696"/>
-        <pc:sldMkLst>
-          <pc:docMk/>
-          <pc:sldMk cId="3242670140" sldId="761"/>
-        </pc:sldMkLst>
-      </pc:sldChg>
       <pc:sldChg chg="modSp mod">
         <pc:chgData name="Mitchell Wand" userId="de9b44c55c049659" providerId="LiveId" clId="{7A9D5940-B2CC-47DD-AF5E-71219F1A1E26}" dt="2026-09-03T17:45:34.208" v="1870" actId="20577"/>
         <pc:sldMkLst>
@@ -422,12 +346,28 @@
           <pc:sldMk cId="1815343659" sldId="772"/>
         </pc:sldMkLst>
       </pc:sldChg>
-      <pc:sldChg chg="del">
-        <pc:chgData name="Mitchell Wand" userId="de9b44c55c049659" providerId="LiveId" clId="{7A9D5940-B2CC-47DD-AF5E-71219F1A1E26}" dt="2026-09-03T15:56:06.866" v="421" actId="2696"/>
+      <pc:sldChg chg="modSp mod modNotesTx">
+        <pc:chgData name="Mitchell Wand" userId="de9b44c55c049659" providerId="LiveId" clId="{7A9D5940-B2CC-47DD-AF5E-71219F1A1E26}" dt="2026-09-09T17:20:24.372" v="2783" actId="20577"/>
         <pc:sldMkLst>
           <pc:docMk/>
-          <pc:sldMk cId="1703380474" sldId="775"/>
+          <pc:sldMk cId="1670456934" sldId="773"/>
         </pc:sldMkLst>
+        <pc:spChg chg="mod">
+          <ac:chgData name="Mitchell Wand" userId="de9b44c55c049659" providerId="LiveId" clId="{7A9D5940-B2CC-47DD-AF5E-71219F1A1E26}" dt="2026-09-09T17:20:24.372" v="2783" actId="20577"/>
+          <ac:spMkLst>
+            <pc:docMk/>
+            <pc:sldMk cId="1670456934" sldId="773"/>
+            <ac:spMk id="2" creationId="{04ED29E7-FA78-AC12-A0FD-5D11FD465ED0}"/>
+          </ac:spMkLst>
+        </pc:spChg>
+        <pc:spChg chg="mod">
+          <ac:chgData name="Mitchell Wand" userId="de9b44c55c049659" providerId="LiveId" clId="{7A9D5940-B2CC-47DD-AF5E-71219F1A1E26}" dt="2026-09-09T17:17:04.535" v="2334" actId="20577"/>
+          <ac:spMkLst>
+            <pc:docMk/>
+            <pc:sldMk cId="1670456934" sldId="773"/>
+            <ac:spMk id="5" creationId="{7D6B298E-C0FC-F32F-6134-C4AA1F7B4CA0}"/>
+          </ac:spMkLst>
+        </pc:spChg>
       </pc:sldChg>
       <pc:sldChg chg="modSp mod ord">
         <pc:chgData name="Mitchell Wand" userId="de9b44c55c049659" providerId="LiveId" clId="{7A9D5940-B2CC-47DD-AF5E-71219F1A1E26}" dt="2026-09-03T17:45:19.973" v="1866" actId="6549"/>
@@ -444,37 +384,45 @@
           </ac:spMkLst>
         </pc:spChg>
       </pc:sldChg>
-      <pc:sldChg chg="modSp mod ord">
-        <pc:chgData name="Mitchell Wand" userId="de9b44c55c049659" providerId="LiveId" clId="{7A9D5940-B2CC-47DD-AF5E-71219F1A1E26}" dt="2026-09-03T16:47:30.506" v="1133" actId="20577"/>
+      <pc:sldChg chg="addSp modSp mod">
+        <pc:chgData name="Mitchell Wand" userId="de9b44c55c049659" providerId="LiveId" clId="{7A9D5940-B2CC-47DD-AF5E-71219F1A1E26}" dt="2026-09-09T19:59:18.801" v="3553" actId="13926"/>
         <pc:sldMkLst>
           <pc:docMk/>
-          <pc:sldMk cId="3075355761" sldId="778"/>
+          <pc:sldMk cId="512191831" sldId="781"/>
         </pc:sldMkLst>
         <pc:spChg chg="mod">
-          <ac:chgData name="Mitchell Wand" userId="de9b44c55c049659" providerId="LiveId" clId="{7A9D5940-B2CC-47DD-AF5E-71219F1A1E26}" dt="2026-09-03T16:47:17.666" v="1132" actId="20577"/>
+          <ac:chgData name="Mitchell Wand" userId="de9b44c55c049659" providerId="LiveId" clId="{7A9D5940-B2CC-47DD-AF5E-71219F1A1E26}" dt="2026-09-09T19:54:22.456" v="3474" actId="20577"/>
           <ac:spMkLst>
             <pc:docMk/>
-            <pc:sldMk cId="3075355761" sldId="778"/>
-            <ac:spMk id="2" creationId="{D71480DC-79A9-A0E5-AF4B-F0D07BBBC51A}"/>
+            <pc:sldMk cId="512191831" sldId="781"/>
+            <ac:spMk id="2" creationId="{74839C51-C3AA-E6F2-B971-C8EAA4F7E9E0}"/>
+          </ac:spMkLst>
+        </pc:spChg>
+        <pc:spChg chg="add mod">
+          <ac:chgData name="Mitchell Wand" userId="de9b44c55c049659" providerId="LiveId" clId="{7A9D5940-B2CC-47DD-AF5E-71219F1A1E26}" dt="2026-09-09T19:56:19.852" v="3515" actId="1076"/>
+          <ac:spMkLst>
+            <pc:docMk/>
+            <pc:sldMk cId="512191831" sldId="781"/>
+            <ac:spMk id="5" creationId="{AEB28982-C1E9-2558-D95A-39769274C0B8}"/>
           </ac:spMkLst>
         </pc:spChg>
         <pc:spChg chg="mod">
-          <ac:chgData name="Mitchell Wand" userId="de9b44c55c049659" providerId="LiveId" clId="{7A9D5940-B2CC-47DD-AF5E-71219F1A1E26}" dt="2026-09-03T16:47:30.506" v="1133" actId="20577"/>
+          <ac:chgData name="Mitchell Wand" userId="de9b44c55c049659" providerId="LiveId" clId="{7A9D5940-B2CC-47DD-AF5E-71219F1A1E26}" dt="2026-09-09T19:59:18.801" v="3553" actId="13926"/>
           <ac:spMkLst>
             <pc:docMk/>
-            <pc:sldMk cId="3075355761" sldId="778"/>
-            <ac:spMk id="3" creationId="{E666A41D-A78F-55BB-93F3-43479609AF2C}"/>
+            <pc:sldMk cId="512191831" sldId="781"/>
+            <ac:spMk id="8" creationId="{D10ED06E-D37C-B805-ED36-27F6070D4F16}"/>
           </ac:spMkLst>
         </pc:spChg>
       </pc:sldChg>
       <pc:sldChg chg="modSp mod">
-        <pc:chgData name="Mitchell Wand" userId="de9b44c55c049659" providerId="LiveId" clId="{7A9D5940-B2CC-47DD-AF5E-71219F1A1E26}" dt="2026-09-03T16:52:58.195" v="1303" actId="20577"/>
+        <pc:chgData name="Mitchell Wand" userId="de9b44c55c049659" providerId="LiveId" clId="{7A9D5940-B2CC-47DD-AF5E-71219F1A1E26}" dt="2026-09-09T20:00:11.644" v="3586" actId="20577"/>
         <pc:sldMkLst>
           <pc:docMk/>
           <pc:sldMk cId="2053962974" sldId="783"/>
         </pc:sldMkLst>
         <pc:spChg chg="mod">
-          <ac:chgData name="Mitchell Wand" userId="de9b44c55c049659" providerId="LiveId" clId="{7A9D5940-B2CC-47DD-AF5E-71219F1A1E26}" dt="2026-09-03T16:52:02.394" v="1235" actId="13926"/>
+          <ac:chgData name="Mitchell Wand" userId="de9b44c55c049659" providerId="LiveId" clId="{7A9D5940-B2CC-47DD-AF5E-71219F1A1E26}" dt="2026-09-09T19:59:58.513" v="3577" actId="20577"/>
           <ac:spMkLst>
             <pc:docMk/>
             <pc:sldMk cId="2053962974" sldId="783"/>
@@ -482,11 +430,41 @@
           </ac:spMkLst>
         </pc:spChg>
         <pc:spChg chg="mod">
-          <ac:chgData name="Mitchell Wand" userId="de9b44c55c049659" providerId="LiveId" clId="{7A9D5940-B2CC-47DD-AF5E-71219F1A1E26}" dt="2026-09-03T16:52:58.195" v="1303" actId="20577"/>
+          <ac:chgData name="Mitchell Wand" userId="de9b44c55c049659" providerId="LiveId" clId="{7A9D5940-B2CC-47DD-AF5E-71219F1A1E26}" dt="2026-09-09T20:00:11.644" v="3586" actId="20577"/>
           <ac:spMkLst>
             <pc:docMk/>
             <pc:sldMk cId="2053962974" sldId="783"/>
             <ac:spMk id="7" creationId="{1D7B0D2A-A2FB-BBB2-D55C-92AC0E0A7BB8}"/>
+          </ac:spMkLst>
+        </pc:spChg>
+      </pc:sldChg>
+      <pc:sldChg chg="modSp mod">
+        <pc:chgData name="Mitchell Wand" userId="de9b44c55c049659" providerId="LiveId" clId="{7A9D5940-B2CC-47DD-AF5E-71219F1A1E26}" dt="2026-09-09T19:57:39.535" v="3536" actId="14100"/>
+        <pc:sldMkLst>
+          <pc:docMk/>
+          <pc:sldMk cId="2620882723" sldId="784"/>
+        </pc:sldMkLst>
+        <pc:spChg chg="mod">
+          <ac:chgData name="Mitchell Wand" userId="de9b44c55c049659" providerId="LiveId" clId="{7A9D5940-B2CC-47DD-AF5E-71219F1A1E26}" dt="2026-09-09T19:57:39.535" v="3536" actId="14100"/>
+          <ac:spMkLst>
+            <pc:docMk/>
+            <pc:sldMk cId="2620882723" sldId="784"/>
+            <ac:spMk id="6" creationId="{D6443323-3D04-903B-8652-F1987EB8BDA6}"/>
+          </ac:spMkLst>
+        </pc:spChg>
+      </pc:sldChg>
+      <pc:sldChg chg="modSp mod">
+        <pc:chgData name="Mitchell Wand" userId="de9b44c55c049659" providerId="LiveId" clId="{7A9D5940-B2CC-47DD-AF5E-71219F1A1E26}" dt="2026-09-09T19:57:53.135" v="3543" actId="20577"/>
+        <pc:sldMkLst>
+          <pc:docMk/>
+          <pc:sldMk cId="2563265548" sldId="785"/>
+        </pc:sldMkLst>
+        <pc:spChg chg="mod">
+          <ac:chgData name="Mitchell Wand" userId="de9b44c55c049659" providerId="LiveId" clId="{7A9D5940-B2CC-47DD-AF5E-71219F1A1E26}" dt="2026-09-09T19:57:53.135" v="3543" actId="20577"/>
+          <ac:spMkLst>
+            <pc:docMk/>
+            <pc:sldMk cId="2563265548" sldId="785"/>
+            <ac:spMk id="6" creationId="{1AA21049-DF49-FBA5-D054-1CD6A3079C53}"/>
           </ac:spMkLst>
         </pc:spChg>
       </pc:sldChg>
@@ -553,7 +531,7 @@
         </pc:spChg>
       </pc:sldChg>
       <pc:sldChg chg="addSp delSp modSp new mod ord modClrScheme modAnim chgLayout modNotesTx">
-        <pc:chgData name="Mitchell Wand" userId="de9b44c55c049659" providerId="LiveId" clId="{7A9D5940-B2CC-47DD-AF5E-71219F1A1E26}" dt="2026-09-03T17:49:43.910" v="2217" actId="20577"/>
+        <pc:chgData name="Mitchell Wand" userId="de9b44c55c049659" providerId="LiveId" clId="{7A9D5940-B2CC-47DD-AF5E-71219F1A1E26}" dt="2026-09-09T17:22:21.739" v="3004" actId="20577"/>
         <pc:sldMkLst>
           <pc:docMk/>
           <pc:sldMk cId="538486171" sldId="794"/>
@@ -564,14 +542,6 @@
             <pc:docMk/>
             <pc:sldMk cId="538486171" sldId="794"/>
             <ac:spMk id="2" creationId="{E9CF2938-A643-8A0E-686D-9B021B7A304E}"/>
-          </ac:spMkLst>
-        </pc:spChg>
-        <pc:spChg chg="del">
-          <ac:chgData name="Mitchell Wand" userId="de9b44c55c049659" providerId="LiveId" clId="{7A9D5940-B2CC-47DD-AF5E-71219F1A1E26}" dt="2026-09-03T15:39:09.230" v="112" actId="700"/>
-          <ac:spMkLst>
-            <pc:docMk/>
-            <pc:sldMk cId="538486171" sldId="794"/>
-            <ac:spMk id="3" creationId="{FE6219E1-6A11-D849-DC51-5497B7B7DDCE}"/>
           </ac:spMkLst>
         </pc:spChg>
         <pc:spChg chg="mod ord">
@@ -623,8 +593,8 @@
           </ac:cxnSpMkLst>
         </pc:cxnChg>
       </pc:sldChg>
-      <pc:sldChg chg="addSp modSp new mod modAnim">
-        <pc:chgData name="Mitchell Wand" userId="de9b44c55c049659" providerId="LiveId" clId="{7A9D5940-B2CC-47DD-AF5E-71219F1A1E26}" dt="2026-09-03T16:54:15.053" v="1320" actId="20577"/>
+      <pc:sldChg chg="addSp modSp new mod modAnim modNotesTx">
+        <pc:chgData name="Mitchell Wand" userId="de9b44c55c049659" providerId="LiveId" clId="{7A9D5940-B2CC-47DD-AF5E-71219F1A1E26}" dt="2026-09-09T17:24:42.035" v="3312" actId="20577"/>
         <pc:sldMkLst>
           <pc:docMk/>
           <pc:sldMk cId="2016471653" sldId="795"/>
@@ -701,37 +671,6 @@
           </ac:spMkLst>
         </pc:spChg>
       </pc:sldChg>
-      <pc:sldChg chg="addSp delSp modSp new del mod">
-        <pc:chgData name="Mitchell Wand" userId="de9b44c55c049659" providerId="LiveId" clId="{7A9D5940-B2CC-47DD-AF5E-71219F1A1E26}" dt="2026-09-03T16:42:27.958" v="954" actId="2696"/>
-        <pc:sldMkLst>
-          <pc:docMk/>
-          <pc:sldMk cId="3002712502" sldId="797"/>
-        </pc:sldMkLst>
-        <pc:spChg chg="mod">
-          <ac:chgData name="Mitchell Wand" userId="de9b44c55c049659" providerId="LiveId" clId="{7A9D5940-B2CC-47DD-AF5E-71219F1A1E26}" dt="2026-09-03T16:39:26.009" v="876" actId="20577"/>
-          <ac:spMkLst>
-            <pc:docMk/>
-            <pc:sldMk cId="3002712502" sldId="797"/>
-            <ac:spMk id="2" creationId="{D3052515-06D7-1728-0CFD-01114AA7022A}"/>
-          </ac:spMkLst>
-        </pc:spChg>
-        <pc:spChg chg="del">
-          <ac:chgData name="Mitchell Wand" userId="de9b44c55c049659" providerId="LiveId" clId="{7A9D5940-B2CC-47DD-AF5E-71219F1A1E26}" dt="2026-09-03T16:39:55.873" v="877" actId="22"/>
-          <ac:spMkLst>
-            <pc:docMk/>
-            <pc:sldMk cId="3002712502" sldId="797"/>
-            <ac:spMk id="3" creationId="{039A7A18-5BE5-100E-C058-7E22B1CCB277}"/>
-          </ac:spMkLst>
-        </pc:spChg>
-        <pc:picChg chg="add mod ord">
-          <ac:chgData name="Mitchell Wand" userId="de9b44c55c049659" providerId="LiveId" clId="{7A9D5940-B2CC-47DD-AF5E-71219F1A1E26}" dt="2026-09-03T16:39:55.873" v="877" actId="22"/>
-          <ac:picMkLst>
-            <pc:docMk/>
-            <pc:sldMk cId="3002712502" sldId="797"/>
-            <ac:picMk id="6" creationId="{5B055857-092E-B485-95A1-DADBBD16A948}"/>
-          </ac:picMkLst>
-        </pc:picChg>
-      </pc:sldChg>
       <pc:sldChg chg="addSp delSp modSp new mod modAnim">
         <pc:chgData name="Mitchell Wand" userId="de9b44c55c049659" providerId="LiveId" clId="{7A9D5940-B2CC-47DD-AF5E-71219F1A1E26}" dt="2026-09-03T17:00:45.576" v="1594" actId="20577"/>
         <pc:sldMkLst>
@@ -744,22 +683,6 @@
             <pc:docMk/>
             <pc:sldMk cId="4128061325" sldId="798"/>
             <ac:spMk id="2" creationId="{8067BCFC-9D5C-1224-333C-71A2F4738E4F}"/>
-          </ac:spMkLst>
-        </pc:spChg>
-        <pc:spChg chg="del">
-          <ac:chgData name="Mitchell Wand" userId="de9b44c55c049659" providerId="LiveId" clId="{7A9D5940-B2CC-47DD-AF5E-71219F1A1E26}" dt="2026-09-03T16:41:09.421" v="883" actId="478"/>
-          <ac:spMkLst>
-            <pc:docMk/>
-            <pc:sldMk cId="4128061325" sldId="798"/>
-            <ac:spMk id="3" creationId="{797E8F06-8845-B85F-4891-AF844D62A446}"/>
-          </ac:spMkLst>
-        </pc:spChg>
-        <pc:spChg chg="add del">
-          <ac:chgData name="Mitchell Wand" userId="de9b44c55c049659" providerId="LiveId" clId="{7A9D5940-B2CC-47DD-AF5E-71219F1A1E26}" dt="2026-09-03T16:40:55.336" v="880" actId="478"/>
-          <ac:spMkLst>
-            <pc:docMk/>
-            <pc:sldMk cId="4128061325" sldId="798"/>
-            <ac:spMk id="6" creationId="{B45E89E4-03C3-5ADD-9986-06DD56915EDF}"/>
           </ac:spMkLst>
         </pc:spChg>
         <pc:spChg chg="add mod">
@@ -882,7 +805,7 @@
           <a:p>
             <a:fld id="{7C7E5181-6CF5-45F7-A87A-E0E0B1FD7549}" type="datetimeFigureOut">
               <a:rPr lang="en-US" smtClean="0"/>
-              <a:t>9/7/2026</a:t>
+              <a:t>9/9/2026</a:t>
             </a:fld>
             <a:endParaRPr lang="en-US"/>
           </a:p>
@@ -1417,13 +1340,16 @@
           <a:p>
             <a:r>
               <a:rPr lang="en-US" dirty="0"/>
-              <a:t>Here’s our trivial controller again, but this time using </a:t>
+              <a:t>Here’s our trivial controller again, but this time with an explicit description of what requests are valid, and using the “</a:t>
             </a:r>
             <a:r>
               <a:rPr lang="en-US" dirty="0" err="1"/>
               <a:t>zod</a:t>
             </a:r>
-            <a:endParaRPr lang="en-US" dirty="0"/>
+            <a:r>
+              <a:rPr lang="en-US" dirty="0"/>
+              <a:t>” package to validate each request.</a:t>
+            </a:r>
           </a:p>
         </p:txBody>
       </p:sp>
@@ -1464,6 +1390,98 @@
 </file>
 
 <file path=ppt/notesSlides/notesSlide12.xml><?xml version="1.0" encoding="utf-8"?>
+<p:notes xmlns:a="http://schemas.openxmlformats.org/drawingml/2006/main" xmlns:r="http://schemas.openxmlformats.org/officeDocument/2006/relationships" xmlns:p="http://schemas.openxmlformats.org/presentationml/2006/main">
+  <p:cSld>
+    <p:spTree>
+      <p:nvGrpSpPr>
+        <p:cNvPr id="1" name=""/>
+        <p:cNvGrpSpPr/>
+        <p:nvPr/>
+      </p:nvGrpSpPr>
+      <p:grpSpPr>
+        <a:xfrm>
+          <a:off x="0" y="0"/>
+          <a:ext cx="0" cy="0"/>
+          <a:chOff x="0" y="0"/>
+          <a:chExt cx="0" cy="0"/>
+        </a:xfrm>
+      </p:grpSpPr>
+      <p:sp>
+        <p:nvSpPr>
+          <p:cNvPr id="2" name="Slide Image Placeholder 1"/>
+          <p:cNvSpPr>
+            <a:spLocks noGrp="1" noRot="1" noChangeAspect="1"/>
+          </p:cNvSpPr>
+          <p:nvPr>
+            <p:ph type="sldImg"/>
+          </p:nvPr>
+        </p:nvSpPr>
+        <p:spPr/>
+      </p:sp>
+      <p:sp>
+        <p:nvSpPr>
+          <p:cNvPr id="3" name="Notes Placeholder 2"/>
+          <p:cNvSpPr>
+            <a:spLocks noGrp="1"/>
+          </p:cNvSpPr>
+          <p:nvPr>
+            <p:ph type="body" idx="1"/>
+          </p:nvPr>
+        </p:nvSpPr>
+        <p:spPr/>
+        <p:txBody>
+          <a:bodyPr/>
+          <a:lstStyle/>
+          <a:p>
+            <a:r>
+              <a:rPr lang="en-US" dirty="0"/>
+              <a:t>The controller doesn’t contain any business logic beyond validating the requests; instead it calls the “service layer” to compute the data for the response; then the controller packages the data into an http response &amp; </a:t>
+            </a:r>
+            <a:r>
+              <a:rPr lang="en-US"/>
+              <a:t>sends it.</a:t>
+            </a:r>
+            <a:endParaRPr lang="en-US" dirty="0"/>
+          </a:p>
+        </p:txBody>
+      </p:sp>
+      <p:sp>
+        <p:nvSpPr>
+          <p:cNvPr id="4" name="Slide Number Placeholder 3"/>
+          <p:cNvSpPr>
+            <a:spLocks noGrp="1"/>
+          </p:cNvSpPr>
+          <p:nvPr>
+            <p:ph type="sldNum" sz="quarter" idx="5"/>
+          </p:nvPr>
+        </p:nvSpPr>
+        <p:spPr/>
+        <p:txBody>
+          <a:bodyPr/>
+          <a:lstStyle/>
+          <a:p>
+            <a:fld id="{07937F07-1250-4CCE-B198-1B2887014F41}" type="slidenum">
+              <a:rPr lang="en-US" smtClean="0"/>
+              <a:t>16</a:t>
+            </a:fld>
+            <a:endParaRPr lang="en-US"/>
+          </a:p>
+        </p:txBody>
+      </p:sp>
+    </p:spTree>
+    <p:extLst>
+      <p:ext uri="{BB962C8B-B14F-4D97-AF65-F5344CB8AC3E}">
+        <p14:creationId xmlns:p14="http://schemas.microsoft.com/office/powerpoint/2010/main" val="231833908"/>
+      </p:ext>
+    </p:extLst>
+  </p:cSld>
+  <p:clrMapOvr>
+    <a:masterClrMapping/>
+  </p:clrMapOvr>
+</p:notes>
+</file>
+
+<file path=ppt/notesSlides/notesSlide13.xml><?xml version="1.0" encoding="utf-8"?>
 <p:notes xmlns:a="http://schemas.openxmlformats.org/drawingml/2006/main" xmlns:r="http://schemas.openxmlformats.org/officeDocument/2006/relationships" xmlns:p="http://schemas.openxmlformats.org/presentationml/2006/main">
   <p:cSld>
     <p:spTree>
@@ -1653,7 +1671,7 @@
 </p:notes>
 </file>
 
-<file path=ppt/notesSlides/notesSlide13.xml><?xml version="1.0" encoding="utf-8"?>
+<file path=ppt/notesSlides/notesSlide14.xml><?xml version="1.0" encoding="utf-8"?>
 <p:notes xmlns:a="http://schemas.openxmlformats.org/drawingml/2006/main" xmlns:r="http://schemas.openxmlformats.org/officeDocument/2006/relationships" xmlns:p="http://schemas.openxmlformats.org/presentationml/2006/main">
   <p:cSld>
     <p:spTree>
@@ -1843,7 +1861,7 @@
 </p:notes>
 </file>
 
-<file path=ppt/notesSlides/notesSlide14.xml><?xml version="1.0" encoding="utf-8"?>
+<file path=ppt/notesSlides/notesSlide15.xml><?xml version="1.0" encoding="utf-8"?>
 <p:notes xmlns:a="http://schemas.openxmlformats.org/drawingml/2006/main" xmlns:r="http://schemas.openxmlformats.org/officeDocument/2006/relationships" xmlns:p="http://schemas.openxmlformats.org/presentationml/2006/main">
   <p:cSld>
     <p:spTree>
@@ -1951,7 +1969,7 @@
 </p:notes>
 </file>
 
-<file path=ppt/notesSlides/notesSlide15.xml><?xml version="1.0" encoding="utf-8"?>
+<file path=ppt/notesSlides/notesSlide16.xml><?xml version="1.0" encoding="utf-8"?>
 <p:notes xmlns:a="http://schemas.openxmlformats.org/drawingml/2006/main" xmlns:r="http://schemas.openxmlformats.org/officeDocument/2006/relationships" xmlns:p="http://schemas.openxmlformats.org/presentationml/2006/main">
   <p:cSld>
     <p:spTree>
@@ -2119,121 +2137,6 @@
 </p:notes>
 </file>
 
-<file path=ppt/notesSlides/notesSlide16.xml><?xml version="1.0" encoding="utf-8"?>
-<p:notes xmlns:a="http://schemas.openxmlformats.org/drawingml/2006/main" xmlns:r="http://schemas.openxmlformats.org/officeDocument/2006/relationships" xmlns:p="http://schemas.openxmlformats.org/presentationml/2006/main">
-  <p:cSld>
-    <p:spTree>
-      <p:nvGrpSpPr>
-        <p:cNvPr id="1" name=""/>
-        <p:cNvGrpSpPr/>
-        <p:nvPr/>
-      </p:nvGrpSpPr>
-      <p:grpSpPr>
-        <a:xfrm>
-          <a:off x="0" y="0"/>
-          <a:ext cx="0" cy="0"/>
-          <a:chOff x="0" y="0"/>
-          <a:chExt cx="0" cy="0"/>
-        </a:xfrm>
-      </p:grpSpPr>
-      <p:sp>
-        <p:nvSpPr>
-          <p:cNvPr id="2" name="Slide Image Placeholder 1"/>
-          <p:cNvSpPr>
-            <a:spLocks noGrp="1" noRot="1" noChangeAspect="1"/>
-          </p:cNvSpPr>
-          <p:nvPr>
-            <p:ph type="sldImg"/>
-          </p:nvPr>
-        </p:nvSpPr>
-        <p:spPr/>
-      </p:sp>
-      <p:sp>
-        <p:nvSpPr>
-          <p:cNvPr id="3" name="Notes Placeholder 2"/>
-          <p:cNvSpPr>
-            <a:spLocks noGrp="1"/>
-          </p:cNvSpPr>
-          <p:nvPr>
-            <p:ph type="body" idx="1"/>
-          </p:nvPr>
-        </p:nvSpPr>
-        <p:spPr/>
-        <p:txBody>
-          <a:bodyPr/>
-          <a:lstStyle/>
-          <a:p>
-            <a:pPr marL="0" marR="0" lvl="0" indent="0" algn="l" defTabSz="914400" rtl="0" eaLnBrk="1" fontAlgn="auto" latinLnBrk="0" hangingPunct="1">
-              <a:lnSpc>
-                <a:spcPct val="100000"/>
-              </a:lnSpc>
-              <a:spcBef>
-                <a:spcPts val="0"/>
-              </a:spcBef>
-              <a:spcAft>
-                <a:spcPts val="0"/>
-              </a:spcAft>
-              <a:buClrTx/>
-              <a:buSzTx/>
-              <a:buFontTx/>
-              <a:buNone/>
-              <a:tabLst/>
-              <a:defRPr/>
-            </a:pPr>
-            <a:r>
-              <a:rPr lang="en-US" dirty="0"/>
-              <a:t>by  "long-running", we mean "io-bound", rather than "</a:t>
-            </a:r>
-            <a:r>
-              <a:rPr lang="en-US" dirty="0" err="1"/>
-              <a:t>cpu</a:t>
-            </a:r>
-            <a:r>
-              <a:rPr lang="en-US" dirty="0"/>
-              <a:t>-bound"</a:t>
-            </a:r>
-          </a:p>
-          <a:p>
-            <a:endParaRPr lang="en-US" dirty="0"/>
-          </a:p>
-        </p:txBody>
-      </p:sp>
-      <p:sp>
-        <p:nvSpPr>
-          <p:cNvPr id="4" name="Slide Number Placeholder 3"/>
-          <p:cNvSpPr>
-            <a:spLocks noGrp="1"/>
-          </p:cNvSpPr>
-          <p:nvPr>
-            <p:ph type="sldNum" sz="quarter" idx="5"/>
-          </p:nvPr>
-        </p:nvSpPr>
-        <p:spPr/>
-        <p:txBody>
-          <a:bodyPr/>
-          <a:lstStyle/>
-          <a:p>
-            <a:fld id="{07937F07-1250-4CCE-B198-1B2887014F41}" type="slidenum">
-              <a:rPr lang="en-US" smtClean="0"/>
-              <a:t>22</a:t>
-            </a:fld>
-            <a:endParaRPr lang="en-US"/>
-          </a:p>
-        </p:txBody>
-      </p:sp>
-    </p:spTree>
-    <p:extLst>
-      <p:ext uri="{BB962C8B-B14F-4D97-AF65-F5344CB8AC3E}">
-        <p14:creationId xmlns:p14="http://schemas.microsoft.com/office/powerpoint/2010/main" val="2193791404"/>
-      </p:ext>
-    </p:extLst>
-  </p:cSld>
-  <p:clrMapOvr>
-    <a:masterClrMapping/>
-  </p:clrMapOvr>
-</p:notes>
-</file>
-
 <file path=ppt/notesSlides/notesSlide17.xml><?xml version="1.0" encoding="utf-8"?>
 <p:notes xmlns:a="http://schemas.openxmlformats.org/drawingml/2006/main" xmlns:r="http://schemas.openxmlformats.org/officeDocument/2006/relationships" xmlns:p="http://schemas.openxmlformats.org/presentationml/2006/main">
   <p:cSld>
@@ -2278,14 +2181,38 @@
           <a:bodyPr/>
           <a:lstStyle/>
           <a:p>
+            <a:pPr marL="0" marR="0" lvl="0" indent="0" algn="l" defTabSz="914400" rtl="0" eaLnBrk="1" fontAlgn="auto" latinLnBrk="0" hangingPunct="1">
+              <a:lnSpc>
+                <a:spcPct val="100000"/>
+              </a:lnSpc>
+              <a:spcBef>
+                <a:spcPts val="0"/>
+              </a:spcBef>
+              <a:spcAft>
+                <a:spcPts val="0"/>
+              </a:spcAft>
+              <a:buClrTx/>
+              <a:buSzTx/>
+              <a:buFontTx/>
+              <a:buNone/>
+              <a:tabLst/>
+              <a:defRPr/>
+            </a:pPr>
+            <a:r>
+              <a:rPr lang="en-US" dirty="0"/>
+              <a:t>by  "long-running", we mean "io-bound", rather than "</a:t>
+            </a:r>
             <a:r>
               <a:rPr lang="en-US" dirty="0" err="1"/>
-              <a:t>repo.nameToIDs</a:t>
+              <a:t>cpu</a:t>
             </a:r>
             <a:r>
               <a:rPr lang="en-US" dirty="0"/>
-              <a:t> only returns a Promise for a list of IDs.  'await' suspends the current computation and waits for the repo to fulfill its promise.</a:t>
-            </a:r>
+              <a:t>-bound"</a:t>
+            </a:r>
+          </a:p>
+          <a:p>
+            <a:endParaRPr lang="en-US" dirty="0"/>
           </a:p>
         </p:txBody>
       </p:sp>
@@ -2306,6 +2233,97 @@
           <a:p>
             <a:fld id="{07937F07-1250-4CCE-B198-1B2887014F41}" type="slidenum">
               <a:rPr lang="en-US" smtClean="0"/>
+              <a:t>22</a:t>
+            </a:fld>
+            <a:endParaRPr lang="en-US"/>
+          </a:p>
+        </p:txBody>
+      </p:sp>
+    </p:spTree>
+    <p:extLst>
+      <p:ext uri="{BB962C8B-B14F-4D97-AF65-F5344CB8AC3E}">
+        <p14:creationId xmlns:p14="http://schemas.microsoft.com/office/powerpoint/2010/main" val="2193791404"/>
+      </p:ext>
+    </p:extLst>
+  </p:cSld>
+  <p:clrMapOvr>
+    <a:masterClrMapping/>
+  </p:clrMapOvr>
+</p:notes>
+</file>
+
+<file path=ppt/notesSlides/notesSlide18.xml><?xml version="1.0" encoding="utf-8"?>
+<p:notes xmlns:a="http://schemas.openxmlformats.org/drawingml/2006/main" xmlns:r="http://schemas.openxmlformats.org/officeDocument/2006/relationships" xmlns:p="http://schemas.openxmlformats.org/presentationml/2006/main">
+  <p:cSld>
+    <p:spTree>
+      <p:nvGrpSpPr>
+        <p:cNvPr id="1" name=""/>
+        <p:cNvGrpSpPr/>
+        <p:nvPr/>
+      </p:nvGrpSpPr>
+      <p:grpSpPr>
+        <a:xfrm>
+          <a:off x="0" y="0"/>
+          <a:ext cx="0" cy="0"/>
+          <a:chOff x="0" y="0"/>
+          <a:chExt cx="0" cy="0"/>
+        </a:xfrm>
+      </p:grpSpPr>
+      <p:sp>
+        <p:nvSpPr>
+          <p:cNvPr id="2" name="Slide Image Placeholder 1"/>
+          <p:cNvSpPr>
+            <a:spLocks noGrp="1" noRot="1" noChangeAspect="1"/>
+          </p:cNvSpPr>
+          <p:nvPr>
+            <p:ph type="sldImg"/>
+          </p:nvPr>
+        </p:nvSpPr>
+        <p:spPr/>
+      </p:sp>
+      <p:sp>
+        <p:nvSpPr>
+          <p:cNvPr id="3" name="Notes Placeholder 2"/>
+          <p:cNvSpPr>
+            <a:spLocks noGrp="1"/>
+          </p:cNvSpPr>
+          <p:nvPr>
+            <p:ph type="body" idx="1"/>
+          </p:nvPr>
+        </p:nvSpPr>
+        <p:spPr/>
+        <p:txBody>
+          <a:bodyPr/>
+          <a:lstStyle/>
+          <a:p>
+            <a:r>
+              <a:rPr lang="en-US" dirty="0" err="1"/>
+              <a:t>repo.nameToIDs</a:t>
+            </a:r>
+            <a:r>
+              <a:rPr lang="en-US" dirty="0"/>
+              <a:t> only returns a Promise for a list of IDs.  'await' suspends the current computation and waits for the repo to fulfill its promise.</a:t>
+            </a:r>
+          </a:p>
+        </p:txBody>
+      </p:sp>
+      <p:sp>
+        <p:nvSpPr>
+          <p:cNvPr id="4" name="Slide Number Placeholder 3"/>
+          <p:cNvSpPr>
+            <a:spLocks noGrp="1"/>
+          </p:cNvSpPr>
+          <p:nvPr>
+            <p:ph type="sldNum" sz="quarter" idx="5"/>
+          </p:nvPr>
+        </p:nvSpPr>
+        <p:spPr/>
+        <p:txBody>
+          <a:bodyPr/>
+          <a:lstStyle/>
+          <a:p>
+            <a:fld id="{07937F07-1250-4CCE-B198-1B2887014F41}" type="slidenum">
+              <a:rPr lang="en-US" smtClean="0"/>
               <a:t>24</a:t>
             </a:fld>
             <a:endParaRPr lang="en-US"/>
@@ -2325,7 +2343,7 @@
 </p:notes>
 </file>
 
-<file path=ppt/notesSlides/notesSlide18.xml><?xml version="1.0" encoding="utf-8"?>
+<file path=ppt/notesSlides/notesSlide19.xml><?xml version="1.0" encoding="utf-8"?>
 <p:notes xmlns:a="http://schemas.openxmlformats.org/drawingml/2006/main" xmlns:r="http://schemas.openxmlformats.org/officeDocument/2006/relationships" xmlns:p="http://schemas.openxmlformats.org/presentationml/2006/main">
   <p:cSld>
     <p:spTree>
@@ -2433,90 +2451,6 @@
 </p:notes>
 </file>
 
-<file path=ppt/notesSlides/notesSlide19.xml><?xml version="1.0" encoding="utf-8"?>
-<p:notes xmlns:a="http://schemas.openxmlformats.org/drawingml/2006/main" xmlns:r="http://schemas.openxmlformats.org/officeDocument/2006/relationships" xmlns:p="http://schemas.openxmlformats.org/presentationml/2006/main">
-  <p:cSld>
-    <p:spTree>
-      <p:nvGrpSpPr>
-        <p:cNvPr id="1" name=""/>
-        <p:cNvGrpSpPr/>
-        <p:nvPr/>
-      </p:nvGrpSpPr>
-      <p:grpSpPr>
-        <a:xfrm>
-          <a:off x="0" y="0"/>
-          <a:ext cx="0" cy="0"/>
-          <a:chOff x="0" y="0"/>
-          <a:chExt cx="0" cy="0"/>
-        </a:xfrm>
-      </p:grpSpPr>
-      <p:sp>
-        <p:nvSpPr>
-          <p:cNvPr id="2" name="Slide Image Placeholder 1"/>
-          <p:cNvSpPr>
-            <a:spLocks noGrp="1" noRot="1" noChangeAspect="1"/>
-          </p:cNvSpPr>
-          <p:nvPr>
-            <p:ph type="sldImg"/>
-          </p:nvPr>
-        </p:nvSpPr>
-        <p:spPr/>
-      </p:sp>
-      <p:sp>
-        <p:nvSpPr>
-          <p:cNvPr id="3" name="Notes Placeholder 2"/>
-          <p:cNvSpPr>
-            <a:spLocks noGrp="1"/>
-          </p:cNvSpPr>
-          <p:nvPr>
-            <p:ph type="body" idx="1"/>
-          </p:nvPr>
-        </p:nvSpPr>
-        <p:spPr/>
-        <p:txBody>
-          <a:bodyPr/>
-          <a:lstStyle/>
-          <a:p>
-            <a:endParaRPr lang="en-US" dirty="0"/>
-          </a:p>
-        </p:txBody>
-      </p:sp>
-      <p:sp>
-        <p:nvSpPr>
-          <p:cNvPr id="4" name="Slide Number Placeholder 3"/>
-          <p:cNvSpPr>
-            <a:spLocks noGrp="1"/>
-          </p:cNvSpPr>
-          <p:nvPr>
-            <p:ph type="sldNum" sz="quarter" idx="5"/>
-          </p:nvPr>
-        </p:nvSpPr>
-        <p:spPr/>
-        <p:txBody>
-          <a:bodyPr/>
-          <a:lstStyle/>
-          <a:p>
-            <a:fld id="{07937F07-1250-4CCE-B198-1B2887014F41}" type="slidenum">
-              <a:rPr lang="en-US" smtClean="0"/>
-              <a:t>28</a:t>
-            </a:fld>
-            <a:endParaRPr lang="en-US"/>
-          </a:p>
-        </p:txBody>
-      </p:sp>
-    </p:spTree>
-    <p:extLst>
-      <p:ext uri="{BB962C8B-B14F-4D97-AF65-F5344CB8AC3E}">
-        <p14:creationId xmlns:p14="http://schemas.microsoft.com/office/powerpoint/2010/main" val="808526028"/>
-      </p:ext>
-    </p:extLst>
-  </p:cSld>
-  <p:clrMapOvr>
-    <a:masterClrMapping/>
-  </p:clrMapOvr>
-</p:notes>
-</file>
-
 <file path=ppt/notesSlides/notesSlide2.xml><?xml version="1.0" encoding="utf-8"?>
 <p:notes xmlns:a="http://schemas.openxmlformats.org/drawingml/2006/main" xmlns:r="http://schemas.openxmlformats.org/officeDocument/2006/relationships" xmlns:p="http://schemas.openxmlformats.org/presentationml/2006/main">
   <p:cSld>
@@ -2636,6 +2570,90 @@
     <p:extLst>
       <p:ext uri="{BB962C8B-B14F-4D97-AF65-F5344CB8AC3E}">
         <p14:creationId xmlns:p14="http://schemas.microsoft.com/office/powerpoint/2010/main" val="2396059268"/>
+      </p:ext>
+    </p:extLst>
+  </p:cSld>
+  <p:clrMapOvr>
+    <a:masterClrMapping/>
+  </p:clrMapOvr>
+</p:notes>
+</file>
+
+<file path=ppt/notesSlides/notesSlide20.xml><?xml version="1.0" encoding="utf-8"?>
+<p:notes xmlns:a="http://schemas.openxmlformats.org/drawingml/2006/main" xmlns:r="http://schemas.openxmlformats.org/officeDocument/2006/relationships" xmlns:p="http://schemas.openxmlformats.org/presentationml/2006/main">
+  <p:cSld>
+    <p:spTree>
+      <p:nvGrpSpPr>
+        <p:cNvPr id="1" name=""/>
+        <p:cNvGrpSpPr/>
+        <p:nvPr/>
+      </p:nvGrpSpPr>
+      <p:grpSpPr>
+        <a:xfrm>
+          <a:off x="0" y="0"/>
+          <a:ext cx="0" cy="0"/>
+          <a:chOff x="0" y="0"/>
+          <a:chExt cx="0" cy="0"/>
+        </a:xfrm>
+      </p:grpSpPr>
+      <p:sp>
+        <p:nvSpPr>
+          <p:cNvPr id="2" name="Slide Image Placeholder 1"/>
+          <p:cNvSpPr>
+            <a:spLocks noGrp="1" noRot="1" noChangeAspect="1"/>
+          </p:cNvSpPr>
+          <p:nvPr>
+            <p:ph type="sldImg"/>
+          </p:nvPr>
+        </p:nvSpPr>
+        <p:spPr/>
+      </p:sp>
+      <p:sp>
+        <p:nvSpPr>
+          <p:cNvPr id="3" name="Notes Placeholder 2"/>
+          <p:cNvSpPr>
+            <a:spLocks noGrp="1"/>
+          </p:cNvSpPr>
+          <p:nvPr>
+            <p:ph type="body" idx="1"/>
+          </p:nvPr>
+        </p:nvSpPr>
+        <p:spPr/>
+        <p:txBody>
+          <a:bodyPr/>
+          <a:lstStyle/>
+          <a:p>
+            <a:endParaRPr lang="en-US" dirty="0"/>
+          </a:p>
+        </p:txBody>
+      </p:sp>
+      <p:sp>
+        <p:nvSpPr>
+          <p:cNvPr id="4" name="Slide Number Placeholder 3"/>
+          <p:cNvSpPr>
+            <a:spLocks noGrp="1"/>
+          </p:cNvSpPr>
+          <p:nvPr>
+            <p:ph type="sldNum" sz="quarter" idx="5"/>
+          </p:nvPr>
+        </p:nvSpPr>
+        <p:spPr/>
+        <p:txBody>
+          <a:bodyPr/>
+          <a:lstStyle/>
+          <a:p>
+            <a:fld id="{07937F07-1250-4CCE-B198-1B2887014F41}" type="slidenum">
+              <a:rPr lang="en-US" smtClean="0"/>
+              <a:t>28</a:t>
+            </a:fld>
+            <a:endParaRPr lang="en-US"/>
+          </a:p>
+        </p:txBody>
+      </p:sp>
+    </p:spTree>
+    <p:extLst>
+      <p:ext uri="{BB962C8B-B14F-4D97-AF65-F5344CB8AC3E}">
+        <p14:creationId xmlns:p14="http://schemas.microsoft.com/office/powerpoint/2010/main" val="808526028"/>
       </p:ext>
     </p:extLst>
   </p:cSld>
@@ -3528,7 +3546,7 @@
           <a:p>
             <a:r>
               <a:rPr lang="en-US" dirty="0"/>
-              <a:t>In client-server applications like web apps, it makes sense for a client to treat an HTTP request like a slow function call: the client sends a message to make a function call, and knows it can expect the function call to return with a response message.</a:t>
+              <a:t>In client-server applications like web apps, it makes sense for a client to treat an HTTP request like a slow function call: the client sends a message to make a function call, and knows it can expect the function call to return with a response message. Note: a true REST protocol also involves some conventions about the design of the endpoints (e.g. /cities and /states in the diagram), but we don’t need to worry about that right now.</a:t>
             </a:r>
           </a:p>
           <a:p>
@@ -3589,15 +3607,7 @@
             </a:br>
             <a:r>
               <a:rPr lang="en-US" i="0" dirty="0"/>
-              <a:t>(Too much detail </a:t>
-            </a:r>
-            <a:r>
-              <a:rPr lang="en-US" i="0"/>
-              <a:t>for lecture: What </a:t>
-            </a:r>
-            <a:r>
-              <a:rPr lang="en-US" i="0" dirty="0"/>
-              <a:t>aspects? Well, the </a:t>
+              <a:t>(Too much detail for lecture: What aspects? Well, the </a:t>
             </a:r>
             <a:r>
               <a:rPr lang="en-US" i="0" dirty="0" err="1"/>
@@ -4076,7 +4086,7 @@
           <a:p>
             <a:fld id="{5D2A64DE-480B-420F-9649-4F8E696E08E0}" type="datetime1">
               <a:rPr lang="en-US" smtClean="0"/>
-              <a:t>9/7/2026</a:t>
+              <a:t>9/9/2026</a:t>
             </a:fld>
             <a:endParaRPr lang="en-US"/>
           </a:p>
@@ -4400,7 +4410,7 @@
           <a:p>
             <a:fld id="{EA476A42-A091-4468-A075-64A31BE59948}" type="datetime1">
               <a:rPr lang="en-US" smtClean="0"/>
-              <a:t>9/7/2026</a:t>
+              <a:t>9/9/2026</a:t>
             </a:fld>
             <a:endParaRPr lang="en-US"/>
           </a:p>
@@ -4598,7 +4608,7 @@
           <a:p>
             <a:fld id="{0D3616D0-8311-4107-9726-6B805E7D05BA}" type="datetime1">
               <a:rPr lang="en-US" smtClean="0"/>
-              <a:t>9/7/2026</a:t>
+              <a:t>9/9/2026</a:t>
             </a:fld>
             <a:endParaRPr lang="en-US"/>
           </a:p>
@@ -4806,7 +4816,7 @@
           <a:p>
             <a:fld id="{3BC2557A-5C88-417A-A763-5AC779462A5F}" type="datetime1">
               <a:rPr lang="en-US" smtClean="0"/>
-              <a:t>9/7/2026</a:t>
+              <a:t>9/9/2026</a:t>
             </a:fld>
             <a:endParaRPr lang="en-US"/>
           </a:p>
@@ -5228,7 +5238,7 @@
           <a:p>
             <a:fld id="{07C7BFD4-467E-4EDE-93EA-052F5B39A4E5}" type="datetime1">
               <a:rPr lang="en-US" smtClean="0"/>
-              <a:t>9/7/2026</a:t>
+              <a:t>9/9/2026</a:t>
             </a:fld>
             <a:endParaRPr lang="en-US"/>
           </a:p>
@@ -5478,7 +5488,7 @@
           <a:p>
             <a:fld id="{07C7BFD4-467E-4EDE-93EA-052F5B39A4E5}" type="datetime1">
               <a:rPr lang="en-US" smtClean="0"/>
-              <a:t>9/7/2026</a:t>
+              <a:t>9/9/2026</a:t>
             </a:fld>
             <a:endParaRPr lang="en-US"/>
           </a:p>
@@ -5660,7 +5670,7 @@
           <a:p>
             <a:fld id="{109E55A0-C911-4F03-82FC-7E5926047D46}" type="datetime1">
               <a:rPr lang="en-US" smtClean="0"/>
-              <a:t>9/7/2026</a:t>
+              <a:t>9/9/2026</a:t>
             </a:fld>
             <a:endParaRPr lang="en-US"/>
           </a:p>
@@ -5973,7 +5983,7 @@
           <a:p>
             <a:fld id="{A533CBE2-D5BE-47AC-ADC2-9CDFC1D0CF90}" type="datetime1">
               <a:rPr lang="en-US" smtClean="0"/>
-              <a:t>9/7/2026</a:t>
+              <a:t>9/9/2026</a:t>
             </a:fld>
             <a:endParaRPr lang="en-US"/>
           </a:p>
@@ -6274,7 +6284,7 @@
           <a:p>
             <a:fld id="{39B7EDB1-CE74-4951-85A2-0B01C2128E28}" type="datetime1">
               <a:rPr lang="en-US" smtClean="0"/>
-              <a:t>9/7/2026</a:t>
+              <a:t>9/9/2026</a:t>
             </a:fld>
             <a:endParaRPr lang="en-US"/>
           </a:p>
@@ -6722,7 +6732,7 @@
           <a:p>
             <a:fld id="{2BC7EB92-A5C2-4807-A9DC-9EDE6CBFB241}" type="datetime1">
               <a:rPr lang="en-US" smtClean="0"/>
-              <a:t>9/7/2026</a:t>
+              <a:t>9/9/2026</a:t>
             </a:fld>
             <a:endParaRPr lang="en-US"/>
           </a:p>
@@ -6835,7 +6845,7 @@
           <a:p>
             <a:fld id="{2B7B7EE0-7771-4CD5-9B2B-3550753A54A1}" type="datetime1">
               <a:rPr lang="en-US" smtClean="0"/>
-              <a:t>9/7/2026</a:t>
+              <a:t>9/9/2026</a:t>
             </a:fld>
             <a:endParaRPr lang="en-US"/>
           </a:p>
@@ -7146,7 +7156,7 @@
           <a:p>
             <a:fld id="{F8B318B3-0E87-4416-A9B8-D891968C2727}" type="datetime1">
               <a:rPr lang="en-US" smtClean="0"/>
-              <a:t>9/7/2026</a:t>
+              <a:t>9/9/2026</a:t>
             </a:fld>
             <a:endParaRPr lang="en-US"/>
           </a:p>
@@ -7387,7 +7397,7 @@
           <a:p>
             <a:fld id="{54D997E8-DDEE-43F1-8D9B-F8A1E11DE488}" type="datetime1">
               <a:rPr lang="en-US" smtClean="0"/>
-              <a:t>9/7/2026</a:t>
+              <a:t>9/9/2026</a:t>
             </a:fld>
             <a:endParaRPr lang="en-US"/>
           </a:p>
@@ -20443,6 +20453,48 @@
               <a:t>At the end of this lesson, you should be able to</a:t>
             </a:r>
           </a:p>
+          <a:p>
+            <a:pPr lvl="1"/>
+            <a:r>
+              <a:rPr lang="en-US" dirty="0"/>
+              <a:t>Explain the role of “client” and “server” in the context of web application programming</a:t>
+            </a:r>
+          </a:p>
+          <a:p>
+            <a:pPr lvl="1"/>
+            <a:r>
+              <a:rPr lang="en-US" dirty="0"/>
+              <a:t>Describe the role of network protocols like http and </a:t>
+            </a:r>
+            <a:r>
+              <a:rPr lang="en-US" dirty="0" err="1"/>
+              <a:t>websockets</a:t>
+            </a:r>
+            <a:r>
+              <a:rPr lang="en-US" dirty="0"/>
+              <a:t> in a distributed system. </a:t>
+            </a:r>
+          </a:p>
+          <a:p>
+            <a:pPr lvl="1"/>
+            <a:r>
+              <a:rPr lang="en-US" dirty="0"/>
+              <a:t>Describe the fundamental differences between the three layers of the controller, service, and repository layers in a C-S-R architecture</a:t>
+            </a:r>
+          </a:p>
+          <a:p>
+            <a:pPr lvl="1"/>
+            <a:r>
+              <a:rPr lang="en-US" dirty="0"/>
+              <a:t>Use async and await to handle long-running procedures in a persistent repository </a:t>
+            </a:r>
+          </a:p>
+          <a:p>
+            <a:pPr marL="0" indent="0">
+              <a:buNone/>
+            </a:pPr>
+            <a:endParaRPr lang="en-US" dirty="0"/>
+          </a:p>
         </p:txBody>
       </p:sp>
       <p:sp>
@@ -21129,7 +21181,7 @@
           <a:p>
             <a:r>
               <a:rPr lang="en-US" dirty="0"/>
-              <a:t>This is documented in the interfaces</a:t>
+              <a:t>We need to change the interface to accommodate this change</a:t>
             </a:r>
           </a:p>
         </p:txBody>
@@ -21177,8 +21229,8 @@
         </p:nvSpPr>
         <p:spPr>
           <a:xfrm>
-            <a:off x="838200" y="1629555"/>
-            <a:ext cx="11145253" cy="3477875"/>
+            <a:off x="162622" y="1662516"/>
+            <a:ext cx="11866756" cy="3170099"/>
           </a:xfrm>
           <a:prstGeom prst="rect">
             <a:avLst/>
@@ -21264,7 +21316,7 @@
                 <a:effectLst/>
                 <a:latin typeface="Consolas" panose="020B0609020204030204" pitchFamily="49" charset="0"/>
               </a:rPr>
-              <a:t>ITranscriptRepo</a:t>
+              <a:t>ITranscriptService</a:t>
             </a:r>
             <a:r>
               <a:rPr lang="en-US" sz="2000" b="0" dirty="0">
@@ -21977,11 +22029,6 @@
               </a:rPr>
               <a:t>:</a:t>
             </a:r>
-          </a:p>
-          <a:p>
-            <a:pPr>
-              <a:buNone/>
-            </a:pPr>
             <a:r>
               <a:rPr lang="en-US" sz="2000" dirty="0">
                 <a:solidFill>
@@ -21989,16 +22036,6 @@
                 </a:solidFill>
                 <a:latin typeface="Consolas" panose="020B0609020204030204" pitchFamily="49" charset="0"/>
               </a:rPr>
-              <a:t>    </a:t>
-            </a:r>
-            <a:r>
-              <a:rPr lang="en-US" sz="2000" b="0" dirty="0">
-                <a:solidFill>
-                  <a:srgbClr val="3B3B3B"/>
-                </a:solidFill>
-                <a:effectLst/>
-                <a:latin typeface="Consolas" panose="020B0609020204030204" pitchFamily="49" charset="0"/>
-              </a:rPr>
               <a:t> </a:t>
             </a:r>
             <a:r>
@@ -22007,6 +22044,9 @@
                   <a:srgbClr val="267F99"/>
                 </a:solidFill>
                 <a:effectLst/>
+                <a:highlight>
+                  <a:srgbClr val="FFFF00"/>
+                </a:highlight>
                 <a:latin typeface="Consolas" panose="020B0609020204030204" pitchFamily="49" charset="0"/>
               </a:rPr>
               <a:t>Promise</a:t>
@@ -22407,6 +22447,177 @@
               </a:solidFill>
               <a:effectLst/>
               <a:latin typeface="Consolas" panose="020B0609020204030204" pitchFamily="49" charset="0"/>
+            </a:endParaRPr>
+          </a:p>
+        </p:txBody>
+      </p:sp>
+      <p:sp>
+        <p:nvSpPr>
+          <p:cNvPr id="5" name="Rectangle: Rounded Corners 4">
+            <a:extLst>
+              <a:ext uri="{FF2B5EF4-FFF2-40B4-BE49-F238E27FC236}">
+                <a16:creationId xmlns:a16="http://schemas.microsoft.com/office/drawing/2014/main" id="{AEB28982-C1E9-2558-D95A-39769274C0B8}"/>
+              </a:ext>
+            </a:extLst>
+          </p:cNvPr>
+          <p:cNvSpPr/>
+          <p:nvPr/>
+        </p:nvSpPr>
+        <p:spPr>
+          <a:xfrm>
+            <a:off x="5599771" y="5347577"/>
+            <a:ext cx="5754029" cy="768626"/>
+          </a:xfrm>
+          <a:prstGeom prst="roundRect">
+            <a:avLst/>
+          </a:prstGeom>
+          <a:solidFill>
+            <a:schemeClr val="accent6">
+              <a:lumMod val="20000"/>
+              <a:lumOff val="80000"/>
+            </a:schemeClr>
+          </a:solidFill>
+          <a:ln>
+            <a:solidFill>
+              <a:srgbClr val="0070C0"/>
+            </a:solidFill>
+          </a:ln>
+        </p:spPr>
+        <p:style>
+          <a:lnRef idx="2">
+            <a:schemeClr val="accent1">
+              <a:shade val="50000"/>
+            </a:schemeClr>
+          </a:lnRef>
+          <a:fillRef idx="1">
+            <a:schemeClr val="accent1"/>
+          </a:fillRef>
+          <a:effectRef idx="0">
+            <a:schemeClr val="accent1"/>
+          </a:effectRef>
+          <a:fontRef idx="minor">
+            <a:schemeClr val="lt1"/>
+          </a:fontRef>
+        </p:style>
+        <p:txBody>
+          <a:bodyPr rtlCol="0" anchor="ctr"/>
+          <a:lstStyle/>
+          <a:p>
+            <a:pPr marL="0" marR="0" lvl="0" indent="0" algn="ctr" defTabSz="914400" rtl="0" eaLnBrk="1" fontAlgn="auto" latinLnBrk="0" hangingPunct="1">
+              <a:lnSpc>
+                <a:spcPct val="100000"/>
+              </a:lnSpc>
+              <a:spcBef>
+                <a:spcPts val="0"/>
+              </a:spcBef>
+              <a:spcAft>
+                <a:spcPts val="0"/>
+              </a:spcAft>
+              <a:buClrTx/>
+              <a:buSzTx/>
+              <a:buFontTx/>
+              <a:buNone/>
+              <a:tabLst/>
+              <a:defRPr/>
+            </a:pPr>
+            <a:r>
+              <a:rPr kumimoji="0" lang="en-US" sz="2400" b="0" i="0" u="none" strike="noStrike" kern="1200" cap="none" spc="0" normalizeH="0" baseline="0" noProof="0" dirty="0" err="1">
+                <a:ln>
+                  <a:noFill/>
+                </a:ln>
+                <a:solidFill>
+                  <a:prstClr val="black"/>
+                </a:solidFill>
+                <a:effectLst/>
+                <a:uLnTx/>
+                <a:uFillTx/>
+                <a:latin typeface="Calibri" panose="020F0502020204030204"/>
+                <a:ea typeface="+mn-ea"/>
+                <a:cs typeface="+mn-cs"/>
+              </a:rPr>
+              <a:t>src</a:t>
+            </a:r>
+            <a:r>
+              <a:rPr kumimoji="0" lang="en-US" sz="2400" b="0" i="0" u="none" strike="noStrike" kern="1200" cap="none" spc="0" normalizeH="0" baseline="0" noProof="0" dirty="0">
+                <a:ln>
+                  <a:noFill/>
+                </a:ln>
+                <a:solidFill>
+                  <a:prstClr val="black"/>
+                </a:solidFill>
+                <a:effectLst/>
+                <a:uLnTx/>
+                <a:uFillTx/>
+                <a:latin typeface="Calibri" panose="020F0502020204030204"/>
+                <a:ea typeface="+mn-ea"/>
+                <a:cs typeface="+mn-cs"/>
+              </a:rPr>
+              <a:t>/</a:t>
+            </a:r>
+            <a:r>
+              <a:rPr kumimoji="0" lang="en-US" sz="2400" b="0" i="0" u="none" strike="noStrike" kern="1200" cap="none" spc="0" normalizeH="0" baseline="0" noProof="0" dirty="0" err="1">
+                <a:ln>
+                  <a:noFill/>
+                </a:ln>
+                <a:solidFill>
+                  <a:prstClr val="black"/>
+                </a:solidFill>
+                <a:effectLst/>
+                <a:uLnTx/>
+                <a:uFillTx/>
+                <a:latin typeface="Calibri" panose="020F0502020204030204"/>
+                <a:ea typeface="+mn-ea"/>
+                <a:cs typeface="+mn-cs"/>
+              </a:rPr>
+              <a:t>withPersistence</a:t>
+            </a:r>
+            <a:r>
+              <a:rPr kumimoji="0" lang="en-US" sz="2400" b="0" i="0" u="none" strike="noStrike" kern="1200" cap="none" spc="0" normalizeH="0" baseline="0" noProof="0" dirty="0">
+                <a:ln>
+                  <a:noFill/>
+                </a:ln>
+                <a:solidFill>
+                  <a:prstClr val="black"/>
+                </a:solidFill>
+                <a:effectLst/>
+                <a:uLnTx/>
+                <a:uFillTx/>
+                <a:latin typeface="Calibri" panose="020F0502020204030204"/>
+                <a:ea typeface="+mn-ea"/>
+                <a:cs typeface="+mn-cs"/>
+              </a:rPr>
+              <a:t>/</a:t>
+            </a:r>
+            <a:r>
+              <a:rPr kumimoji="0" lang="en-US" sz="2400" b="0" i="0" u="none" strike="noStrike" kern="1200" cap="none" spc="0" normalizeH="0" baseline="0" noProof="0" dirty="0" err="1">
+                <a:ln>
+                  <a:noFill/>
+                </a:ln>
+                <a:solidFill>
+                  <a:prstClr val="black"/>
+                </a:solidFill>
+                <a:effectLst/>
+                <a:uLnTx/>
+                <a:uFillTx/>
+                <a:latin typeface="Calibri" panose="020F0502020204030204"/>
+                <a:ea typeface="+mn-ea"/>
+                <a:cs typeface="+mn-cs"/>
+              </a:rPr>
+              <a:t>Itranscript.service.ts</a:t>
+            </a:r>
+            <a:endParaRPr kumimoji="0" lang="en-US" sz="2400" b="0" i="0" u="none" strike="noStrike" kern="1200" cap="none" spc="0" normalizeH="0" baseline="0" noProof="0" dirty="0">
+              <a:ln>
+                <a:noFill/>
+              </a:ln>
+              <a:solidFill>
+                <a:prstClr val="black"/>
+              </a:solidFill>
+              <a:effectLst/>
+              <a:uLnTx/>
+              <a:uFillTx/>
+              <a:latin typeface="Calibri" panose="020F0502020204030204"/>
+              <a:ea typeface="+mn-ea"/>
+              <a:cs typeface="+mn-cs"/>
             </a:endParaRPr>
           </a:p>
         </p:txBody>
@@ -22507,7 +22718,7 @@
           <a:p>
             <a:r>
               <a:rPr lang="en-US" dirty="0" err="1"/>
-              <a:t>repo.nameToIDs</a:t>
+              <a:t>service.nameToIDs</a:t>
             </a:r>
             <a:r>
               <a:rPr lang="en-US" dirty="0"/>
@@ -22869,7 +23080,7 @@
                 <a:effectLst/>
                 <a:latin typeface="Consolas" panose="020B0609020204030204" pitchFamily="49" charset="0"/>
               </a:rPr>
-              <a:t>repo</a:t>
+              <a:t>service</a:t>
             </a:r>
             <a:r>
               <a:rPr lang="en-US" sz="2400" b="0" dirty="0" err="1">
@@ -23067,7 +23278,7 @@
                 <a:effectLst/>
                 <a:latin typeface="Consolas" panose="020B0609020204030204" pitchFamily="49" charset="0"/>
               </a:rPr>
-              <a:t>repo</a:t>
+              <a:t>service</a:t>
             </a:r>
             <a:r>
               <a:rPr lang="en-US" sz="2400" b="0" dirty="0" err="1">
@@ -23204,7 +23415,7 @@
                 </a:solidFill>
                 <a:latin typeface="Consolas" panose="020B0609020204030204" pitchFamily="49" charset="0"/>
               </a:rPr>
-              <a:t>repo</a:t>
+              <a:t>serice</a:t>
             </a:r>
             <a:r>
               <a:rPr lang="en-US" sz="2400" b="0" dirty="0" err="1">
@@ -23450,7 +23661,7 @@
         <p:spPr>
           <a:xfrm>
             <a:off x="472238" y="1720840"/>
-            <a:ext cx="11234488" cy="2677656"/>
+            <a:ext cx="11719762" cy="2677656"/>
           </a:xfrm>
           <a:prstGeom prst="rect">
             <a:avLst/>
@@ -23750,7 +23961,7 @@
                 <a:effectLst/>
                 <a:latin typeface="Consolas" panose="020B0609020204030204" pitchFamily="49" charset="0"/>
               </a:rPr>
-              <a:t>repo</a:t>
+              <a:t>sevice</a:t>
             </a:r>
             <a:r>
               <a:rPr lang="en-US" sz="2400" b="0" dirty="0" err="1">
@@ -23945,7 +24156,7 @@
                 <a:effectLst/>
                 <a:latin typeface="Consolas" panose="020B0609020204030204" pitchFamily="49" charset="0"/>
               </a:rPr>
-              <a:t>repo</a:t>
+              <a:t>service</a:t>
             </a:r>
             <a:r>
               <a:rPr lang="en-US" sz="2400" b="0" dirty="0" err="1">
@@ -24079,7 +24290,7 @@
                 </a:solidFill>
                 <a:latin typeface="Consolas" panose="020B0609020204030204" pitchFamily="49" charset="0"/>
               </a:rPr>
-              <a:t>repo</a:t>
+              <a:t>service</a:t>
             </a:r>
             <a:r>
               <a:rPr lang="en-US" sz="2400" b="0" dirty="0" err="1">
@@ -24714,7 +24925,7 @@
                 <a:effectLst/>
                 <a:latin typeface="Consolas" panose="020B0609020204030204" pitchFamily="49" charset="0"/>
               </a:rPr>
-              <a:t>db</a:t>
+              <a:t>service</a:t>
             </a:r>
             <a:r>
               <a:rPr lang="en-US" sz="2400" b="0" dirty="0" err="1">
@@ -28012,7 +28223,7 @@
           <a:p>
             <a:r>
               <a:rPr lang="en-US" dirty="0"/>
-              <a:t>HTTP is a protocol useful for ”Function-call-like” Design Patterns</a:t>
+              <a:t>HTTP is a protocol useful for remote procedure calls, like REST.</a:t>
             </a:r>
           </a:p>
         </p:txBody>
@@ -28036,7 +28247,7 @@
         <p:spPr>
           <a:xfrm>
             <a:off x="838199" y="1500159"/>
-            <a:ext cx="9427029" cy="5339585"/>
+            <a:ext cx="5441415" cy="5339585"/>
           </a:xfrm>
         </p:spPr>
         <p:txBody>
@@ -28088,56 +28299,13 @@
             </a:r>
             <a:r>
               <a:rPr lang="en-US" dirty="0"/>
-              <a:t>(REST):</a:t>
-            </a:r>
-            <a:br>
+              <a:t>(REST): an RPC where server doesn’t maintain a session or remember specific clients.</a:t>
+            </a:r>
+          </a:p>
+          <a:p>
+            <a:r>
               <a:rPr lang="en-US" dirty="0"/>
-            </a:br>
-            <a:r>
-              <a:rPr lang="en-US" dirty="0"/>
-              <a:t>strictly client/server, server doesn’t</a:t>
-            </a:r>
-            <a:br>
-              <a:rPr lang="en-US" dirty="0"/>
-            </a:br>
-            <a:r>
-              <a:rPr lang="en-US" dirty="0"/>
-              <a:t>maintain a session or remember</a:t>
-            </a:r>
-            <a:br>
-              <a:rPr lang="en-US" dirty="0"/>
-            </a:br>
-            <a:r>
-              <a:rPr lang="en-US" dirty="0"/>
-              <a:t>specific clients</a:t>
-            </a:r>
-          </a:p>
-          <a:p>
-            <a:r>
-              <a:rPr lang="en-US" dirty="0"/>
-              <a:t>A set of routes (like /cities, /states, …)</a:t>
-            </a:r>
-            <a:br>
-              <a:rPr lang="en-US" dirty="0"/>
-            </a:br>
-            <a:r>
-              <a:rPr lang="en-US" dirty="0"/>
-              <a:t>answering HTTP requests </a:t>
-            </a:r>
-            <a:br>
-              <a:rPr lang="en-US" dirty="0"/>
-            </a:br>
-            <a:r>
-              <a:rPr lang="en-US" dirty="0"/>
-              <a:t>is a “</a:t>
-            </a:r>
-            <a:r>
-              <a:rPr lang="en-US" b="1" dirty="0"/>
-              <a:t>REST API</a:t>
-            </a:r>
-            <a:r>
-              <a:rPr lang="en-US" dirty="0"/>
-              <a:t>” </a:t>
+              <a:t>Most of our web apps will use a REST-style design.</a:t>
             </a:r>
           </a:p>
         </p:txBody>

</xml_diff>